<commit_message>
Simplify PPT content to clear everyday language
</commit_message>
<xml_diff>
--- a/DERMO_SCAN_PROJECT_PRESENTATION.pptx
+++ b/DERMO_SCAN_PROJECT_PRESENTATION.pptx
@@ -3124,7 +3124,7 @@
         </p:blipFill>
         <p:spPr>
           <a:xfrm>
-            <a:off x="731520" y="640080"/>
+            <a:off x="731520" y="594360"/>
             <a:ext cx="2926080" cy="1554221"/>
           </a:xfrm>
           <a:prstGeom prst="rect">
@@ -3140,8 +3140,8 @@
         </p:nvSpPr>
         <p:spPr>
           <a:xfrm>
-            <a:off x="731520" y="1645920"/>
-            <a:ext cx="3291840" cy="347472"/>
+            <a:off x="731520" y="1600200"/>
+            <a:ext cx="2926080" cy="329184"/>
           </a:xfrm>
           <a:prstGeom prst="roundRect">
             <a:avLst/>
@@ -3174,7 +3174,7 @@
           <a:lstStyle/>
           <a:p>
             <a:pPr algn="ctr">
-              <a:defRPr sz="1000" b="1">
+              <a:defRPr sz="950" b="1">
                 <a:solidFill>
                   <a:srgbClr val="FFFFFF"/>
                 </a:solidFill>
@@ -3182,7 +3182,7 @@
               </a:defRPr>
             </a:pPr>
             <a:r>
-              <a:t>OFFLINE S-T INTERNSHIP CAPSTONE</a:t>
+              <a:t>AI HEALTHCARE INTERNSHIP PROJECT</a:t>
             </a:r>
           </a:p>
         </p:txBody>
@@ -3195,8 +3195,80 @@
         </p:nvSpPr>
         <p:spPr>
           <a:xfrm>
-            <a:off x="731520" y="2103120"/>
-            <a:ext cx="6217920" cy="1005840"/>
+            <a:off x="731520" y="2029968"/>
+            <a:ext cx="6217920" cy="914400"/>
+          </a:xfrm>
+          <a:prstGeom prst="rect">
+            <a:avLst/>
+          </a:prstGeom>
+          <a:noFill/>
+        </p:spPr>
+        <p:txBody>
+          <a:bodyPr wrap="none">
+            <a:spAutoFit/>
+          </a:bodyPr>
+          <a:lstStyle/>
+          <a:p>
+            <a:pPr>
+              <a:defRPr sz="4400" b="1">
+                <a:solidFill>
+                  <a:srgbClr val="FFFFFF"/>
+                </a:solidFill>
+                <a:latin typeface="Arial"/>
+              </a:defRPr>
+            </a:pPr>
+            <a:r>
+              <a:t>DermoScan</a:t>
+            </a:r>
+          </a:p>
+        </p:txBody>
+      </p:sp>
+      <p:sp>
+        <p:nvSpPr>
+          <p:cNvPr id="5" name="TextBox 4"/>
+          <p:cNvSpPr txBox="1"/>
+          <p:nvPr/>
+        </p:nvSpPr>
+        <p:spPr>
+          <a:xfrm>
+            <a:off x="731520" y="2999232"/>
+            <a:ext cx="6217920" cy="457200"/>
+          </a:xfrm>
+          <a:prstGeom prst="rect">
+            <a:avLst/>
+          </a:prstGeom>
+          <a:noFill/>
+        </p:spPr>
+        <p:txBody>
+          <a:bodyPr wrap="none">
+            <a:spAutoFit/>
+          </a:bodyPr>
+          <a:lstStyle/>
+          <a:p>
+            <a:pPr>
+              <a:defRPr sz="1800" b="1">
+                <a:solidFill>
+                  <a:srgbClr val="0EA5E9"/>
+                </a:solidFill>
+                <a:latin typeface="Arial"/>
+              </a:defRPr>
+            </a:pPr>
+            <a:r>
+              <a:t>Smart Skin Check &amp; Triage Assistant</a:t>
+            </a:r>
+          </a:p>
+        </p:txBody>
+      </p:sp>
+      <p:sp>
+        <p:nvSpPr>
+          <p:cNvPr id="6" name="TextBox 5"/>
+          <p:cNvSpPr txBox="1"/>
+          <p:nvPr/>
+        </p:nvSpPr>
+        <p:spPr>
+          <a:xfrm>
+            <a:off x="731520" y="3520440"/>
+            <a:ext cx="6035040" cy="777240"/>
           </a:xfrm>
           <a:prstGeom prst="rect">
             <a:avLst/>
@@ -3210,79 +3282,7 @@
           <a:lstStyle/>
           <a:p>
             <a:pPr>
-              <a:defRPr sz="4400" b="1">
-                <a:solidFill>
-                  <a:srgbClr val="FFFFFF"/>
-                </a:solidFill>
-                <a:latin typeface="Arial"/>
-              </a:defRPr>
-            </a:pPr>
-            <a:r>
-              <a:t>DermoScan</a:t>
-            </a:r>
-          </a:p>
-        </p:txBody>
-      </p:sp>
-      <p:sp>
-        <p:nvSpPr>
-          <p:cNvPr id="5" name="TextBox 4"/>
-          <p:cNvSpPr txBox="1"/>
-          <p:nvPr/>
-        </p:nvSpPr>
-        <p:spPr>
-          <a:xfrm>
-            <a:off x="731520" y="3108960"/>
-            <a:ext cx="6217920" cy="502920"/>
-          </a:xfrm>
-          <a:prstGeom prst="rect">
-            <a:avLst/>
-          </a:prstGeom>
-          <a:noFill/>
-        </p:spPr>
-        <p:txBody>
-          <a:bodyPr wrap="square">
-            <a:spAutoFit/>
-          </a:bodyPr>
-          <a:lstStyle/>
-          <a:p>
-            <a:pPr>
-              <a:defRPr sz="1700" b="1">
-                <a:solidFill>
-                  <a:srgbClr val="0EA5E9"/>
-                </a:solidFill>
-                <a:latin typeface="Arial"/>
-              </a:defRPr>
-            </a:pPr>
-            <a:r>
-              <a:t>AI-Powered Cutaneous Triage &amp; Morphology Workstation</a:t>
-            </a:r>
-          </a:p>
-        </p:txBody>
-      </p:sp>
-      <p:sp>
-        <p:nvSpPr>
-          <p:cNvPr id="6" name="TextBox 5"/>
-          <p:cNvSpPr txBox="1"/>
-          <p:nvPr/>
-        </p:nvSpPr>
-        <p:spPr>
-          <a:xfrm>
-            <a:off x="731520" y="3703320"/>
-            <a:ext cx="6035040" cy="822960"/>
-          </a:xfrm>
-          <a:prstGeom prst="rect">
-            <a:avLst/>
-          </a:prstGeom>
-          <a:noFill/>
-        </p:spPr>
-        <p:txBody>
-          <a:bodyPr wrap="square">
-            <a:spAutoFit/>
-          </a:bodyPr>
-          <a:lstStyle/>
-          <a:p>
-            <a:pPr>
-              <a:defRPr sz="1200">
+              <a:defRPr sz="1250">
                 <a:solidFill>
                   <a:srgbClr val="94A3B8"/>
                 </a:solidFill>
@@ -3290,7 +3290,7 @@
               </a:defRPr>
             </a:pPr>
             <a:r>
-              <a:t>An intelligent clinical decision support platform designed to bridge primary care dermatological triage with client-side canvas downsampling, 4-quadrant morphology decomposition, and ICD-10-CM harmonization.</a:t>
+              <a:t>Upload a photo of a skin rash or problem and get instant, easy-to-understand AI guidance. Helps you understand what it might be and what safe steps to take before seeing a doctor.</a:t>
             </a:r>
           </a:p>
         </p:txBody>
@@ -3303,8 +3303,8 @@
         </p:nvSpPr>
         <p:spPr>
           <a:xfrm>
-            <a:off x="731520" y="4663440"/>
-            <a:ext cx="6035040" cy="1645920"/>
+            <a:off x="731520" y="4434840"/>
+            <a:ext cx="6035040" cy="1874519"/>
           </a:xfrm>
           <a:prstGeom prst="roundRect">
             <a:avLst/>
@@ -3337,67 +3337,89 @@
           <a:lstStyle/>
           <a:p>
             <a:pPr algn="ctr">
+              <a:defRPr sz="1200" b="1">
+                <a:solidFill>
+                  <a:srgbClr val="FFFFFF"/>
+                </a:solidFill>
+                <a:latin typeface="Arial"/>
+              </a:defRPr>
+            </a:pPr>
+            <a:r>
+              <a:t>Student: Bhumireddy.Vijayesh Vardhan Reddy</a:t>
+            </a:r>
+          </a:p>
+          <a:p>
+            <a:pPr>
+              <a:spcBef>
+                <a:spcPts val="200"/>
+              </a:spcBef>
               <a:defRPr sz="1100" b="1">
                 <a:solidFill>
-                  <a:srgbClr val="FFFFFF"/>
-                </a:solidFill>
-                <a:latin typeface="Arial"/>
-              </a:defRPr>
-            </a:pPr>
-            <a:r>
-              <a:t>Student Developer: Bhumireddy.Vijayesh Vardhan Reddy (Roll No: 72312924)</a:t>
-            </a:r>
-          </a:p>
-          <a:p>
-            <a:pPr>
+                  <a:srgbClr val="0EA5E9"/>
+                </a:solidFill>
+                <a:latin typeface="Arial"/>
+              </a:defRPr>
+            </a:pPr>
+            <a:r>
+              <a:t>University Roll Number: 72312924</a:t>
+            </a:r>
+          </a:p>
+          <a:p>
+            <a:pPr>
+              <a:spcBef>
+                <a:spcPts val="200"/>
+              </a:spcBef>
+              <a:defRPr sz="1050">
+                <a:solidFill>
+                  <a:srgbClr val="94A3B8"/>
+                </a:solidFill>
+                <a:latin typeface="Calibri"/>
+              </a:defRPr>
+            </a:pPr>
+            <a:r>
+              <a:t>Course: B.Tech in Computer Science and Engineering (AI &amp; DS)</a:t>
+            </a:r>
+          </a:p>
+          <a:p>
+            <a:pPr>
+              <a:defRPr sz="1050">
+                <a:solidFill>
+                  <a:srgbClr val="94A3B8"/>
+                </a:solidFill>
+                <a:latin typeface="Calibri"/>
+              </a:defRPr>
+            </a:pPr>
+            <a:r>
+              <a:t>University: CT University, Ludhiana (Punjab), India</a:t>
+            </a:r>
+          </a:p>
+          <a:p>
+            <a:pPr>
+              <a:defRPr sz="1050">
+                <a:solidFill>
+                  <a:srgbClr val="94A3B8"/>
+                </a:solidFill>
+                <a:latin typeface="Calibri"/>
+              </a:defRPr>
+            </a:pPr>
+            <a:r>
+              <a:t>Organization: Data Valley Pvt. Ltd. (in collaboration with APSCHE)</a:t>
+            </a:r>
+          </a:p>
+          <a:p>
+            <a:pPr>
+              <a:spcBef>
+                <a:spcPts val="200"/>
+              </a:spcBef>
               <a:defRPr sz="1000">
                 <a:solidFill>
-                  <a:srgbClr val="94A3B8"/>
+                  <a:srgbClr val="0EA5E9"/>
                 </a:solidFill>
                 <a:latin typeface="Calibri"/>
               </a:defRPr>
             </a:pPr>
             <a:r>
-              <a:t>Program: B.Tech CSE (AI &amp; DS) | Department of Computer Science &amp; Engineering</a:t>
-            </a:r>
-          </a:p>
-          <a:p>
-            <a:pPr>
-              <a:defRPr sz="1000">
-                <a:solidFill>
-                  <a:srgbClr val="94A3B8"/>
-                </a:solidFill>
-                <a:latin typeface="Calibri"/>
-              </a:defRPr>
-            </a:pPr>
-            <a:r>
-              <a:t>Institution: CT UNIVERSITY, Ludhiana (Punjab), India</a:t>
-            </a:r>
-          </a:p>
-          <a:p>
-            <a:pPr>
-              <a:defRPr sz="1000">
-                <a:solidFill>
-                  <a:srgbClr val="94A3B8"/>
-                </a:solidFill>
-                <a:latin typeface="Calibri"/>
-              </a:defRPr>
-            </a:pPr>
-            <a:r>
-              <a:t>Internship Partner: DATAVALLEY Pvt. Ltd. (in collaboration with APSCHE)</a:t>
-            </a:r>
-          </a:p>
-          <a:p>
-            <a:pPr>
-              <a:defRPr sz="950">
-                <a:solidFill>
-                  <a:srgbClr val="0EA5E9"/>
-                </a:solidFill>
-                <a:latin typeface="Calibri"/>
-              </a:defRPr>
-            </a:pPr>
-            <a:r>
-              <a:t>Supervisors: Shaik. Arshad (Data Valley) | Er. Rohit Kumar (CT University)</a:t>
+              <a:t>Guides: Shaik. Arshad (Data Valley) | Er. Rohit Kumar (CT University)</a:t>
             </a:r>
           </a:p>
         </p:txBody>
@@ -3455,8 +3477,8 @@
         </p:nvSpPr>
         <p:spPr>
           <a:xfrm>
-            <a:off x="7406640" y="1005840"/>
-            <a:ext cx="3749039" cy="365760"/>
+            <a:off x="7406640" y="960120"/>
+            <a:ext cx="3749039" cy="320040"/>
           </a:xfrm>
           <a:prstGeom prst="rect">
             <a:avLst/>
@@ -3478,7 +3500,7 @@
               </a:defRPr>
             </a:pPr>
             <a:r>
-              <a:t>DEPLOYED CLINICAL PLATFORM</a:t>
+              <a:t>LIVE PLATFORM &amp; HIGHLIGHTS</a:t>
             </a:r>
           </a:p>
         </p:txBody>
@@ -3491,8 +3513,8 @@
         </p:nvSpPr>
         <p:spPr>
           <a:xfrm>
-            <a:off x="7406640" y="1463040"/>
-            <a:ext cx="3749039" cy="804672"/>
+            <a:off x="7406640" y="1417320"/>
+            <a:ext cx="3749039" cy="822960"/>
           </a:xfrm>
           <a:prstGeom prst="roundRect">
             <a:avLst/>
@@ -3521,45 +3543,45 @@
           </a:fontRef>
         </p:style>
         <p:txBody>
-          <a:bodyPr rtlCol="0" anchor="ctr" wrap="square" lIns="109728" rIns="109728" tIns="73152"/>
+          <a:bodyPr rtlCol="0" anchor="ctr" wrap="square" lIns="137160" rIns="137160" tIns="73152"/>
           <a:lstStyle/>
           <a:p>
             <a:pPr algn="ctr">
               <a:defRPr sz="950" b="1">
                 <a:solidFill>
+                  <a:srgbClr val="0EA5E9"/>
+                </a:solidFill>
+                <a:latin typeface="Arial"/>
+              </a:defRPr>
+            </a:pPr>
+            <a:r>
+              <a:t>Live Website</a:t>
+            </a:r>
+          </a:p>
+          <a:p>
+            <a:pPr>
+              <a:defRPr sz="1100" b="1">
+                <a:solidFill>
+                  <a:srgbClr val="FFFFFF"/>
+                </a:solidFill>
+                <a:latin typeface="Arial"/>
+              </a:defRPr>
+            </a:pPr>
+            <a:r>
+              <a:t>dermo-scan-nesn.vercel.app</a:t>
+            </a:r>
+          </a:p>
+          <a:p>
+            <a:pPr>
+              <a:defRPr sz="900">
+                <a:solidFill>
                   <a:srgbClr val="94A3B8"/>
                 </a:solidFill>
-                <a:latin typeface="Arial"/>
-              </a:defRPr>
-            </a:pPr>
-            <a:r>
-              <a:t>Live Vercel Application</a:t>
-            </a:r>
-          </a:p>
-          <a:p>
-            <a:pPr>
-              <a:defRPr sz="1050" b="1">
-                <a:solidFill>
-                  <a:srgbClr val="FFFFFF"/>
-                </a:solidFill>
-                <a:latin typeface="Arial"/>
-              </a:defRPr>
-            </a:pPr>
-            <a:r>
-              <a:t>https://dermo-scan-nesn.vercel.app/</a:t>
-            </a:r>
-          </a:p>
-          <a:p>
-            <a:pPr>
-              <a:defRPr sz="850">
-                <a:solidFill>
-                  <a:srgbClr val="0EA5E9"/>
-                </a:solidFill>
                 <a:latin typeface="Calibri"/>
               </a:defRPr>
             </a:pPr>
             <a:r>
-              <a:t>Instant Global Edge Deployment on Vercel CDN</a:t>
+              <a:t>Open on any phone or laptop browser; free and live</a:t>
             </a:r>
           </a:p>
         </p:txBody>
@@ -3572,8 +3594,8 @@
         </p:nvSpPr>
         <p:spPr>
           <a:xfrm>
-            <a:off x="7406640" y="2359152"/>
-            <a:ext cx="3749039" cy="804672"/>
+            <a:off x="7406640" y="2331720"/>
+            <a:ext cx="3749039" cy="822960"/>
           </a:xfrm>
           <a:prstGeom prst="roundRect">
             <a:avLst/>
@@ -3602,45 +3624,45 @@
           </a:fontRef>
         </p:style>
         <p:txBody>
-          <a:bodyPr rtlCol="0" anchor="ctr" wrap="square" lIns="109728" rIns="109728" tIns="73152"/>
+          <a:bodyPr rtlCol="0" anchor="ctr" wrap="square" lIns="137160" rIns="137160" tIns="73152"/>
           <a:lstStyle/>
           <a:p>
             <a:pPr algn="ctr">
               <a:defRPr sz="950" b="1">
                 <a:solidFill>
+                  <a:srgbClr val="0EA5E9"/>
+                </a:solidFill>
+                <a:latin typeface="Arial"/>
+              </a:defRPr>
+            </a:pPr>
+            <a:r>
+              <a:t>Source Code</a:t>
+            </a:r>
+          </a:p>
+          <a:p>
+            <a:pPr>
+              <a:defRPr sz="1100" b="1">
+                <a:solidFill>
+                  <a:srgbClr val="FFFFFF"/>
+                </a:solidFill>
+                <a:latin typeface="Arial"/>
+              </a:defRPr>
+            </a:pPr>
+            <a:r>
+              <a:t>github.com/vijayesh26/Dermo-Scan-</a:t>
+            </a:r>
+          </a:p>
+          <a:p>
+            <a:pPr>
+              <a:defRPr sz="900">
+                <a:solidFill>
                   <a:srgbClr val="94A3B8"/>
                 </a:solidFill>
-                <a:latin typeface="Arial"/>
-              </a:defRPr>
-            </a:pPr>
-            <a:r>
-              <a:t>GitHub Repository</a:t>
-            </a:r>
-          </a:p>
-          <a:p>
-            <a:pPr>
-              <a:defRPr sz="1050" b="1">
-                <a:solidFill>
-                  <a:srgbClr val="FFFFFF"/>
-                </a:solidFill>
-                <a:latin typeface="Arial"/>
-              </a:defRPr>
-            </a:pPr>
-            <a:r>
-              <a:t>https://github.com/vijayesh26/Dermo-Scan-</a:t>
-            </a:r>
-          </a:p>
-          <a:p>
-            <a:pPr>
-              <a:defRPr sz="850">
-                <a:solidFill>
-                  <a:srgbClr val="0EA5E9"/>
-                </a:solidFill>
                 <a:latin typeface="Calibri"/>
               </a:defRPr>
             </a:pPr>
             <a:r>
-              <a:t>Complete React 18 &amp; TypeScript 5.7 Codebase</a:t>
+              <a:t>Complete React and TypeScript source code</a:t>
             </a:r>
           </a:p>
         </p:txBody>
@@ -3653,8 +3675,8 @@
         </p:nvSpPr>
         <p:spPr>
           <a:xfrm>
-            <a:off x="7406640" y="3255264"/>
-            <a:ext cx="3749039" cy="804672"/>
+            <a:off x="7406640" y="3246120"/>
+            <a:ext cx="3749039" cy="822960"/>
           </a:xfrm>
           <a:prstGeom prst="roundRect">
             <a:avLst/>
@@ -3683,45 +3705,45 @@
           </a:fontRef>
         </p:style>
         <p:txBody>
-          <a:bodyPr rtlCol="0" anchor="ctr" wrap="square" lIns="109728" rIns="109728" tIns="73152"/>
+          <a:bodyPr rtlCol="0" anchor="ctr" wrap="square" lIns="137160" rIns="137160" tIns="73152"/>
           <a:lstStyle/>
           <a:p>
             <a:pPr algn="ctr">
               <a:defRPr sz="950" b="1">
                 <a:solidFill>
+                  <a:srgbClr val="0EA5E9"/>
+                </a:solidFill>
+                <a:latin typeface="Arial"/>
+              </a:defRPr>
+            </a:pPr>
+            <a:r>
+              <a:t>Easy on the Eyes</a:t>
+            </a:r>
+          </a:p>
+          <a:p>
+            <a:pPr>
+              <a:defRPr sz="1100" b="1">
+                <a:solidFill>
+                  <a:srgbClr val="FFFFFF"/>
+                </a:solidFill>
+                <a:latin typeface="Arial"/>
+              </a:defRPr>
+            </a:pPr>
+            <a:r>
+              <a:t>Calm Medical Blue Design</a:t>
+            </a:r>
+          </a:p>
+          <a:p>
+            <a:pPr>
+              <a:defRPr sz="900">
+                <a:solidFill>
                   <a:srgbClr val="94A3B8"/>
                 </a:solidFill>
-                <a:latin typeface="Arial"/>
-              </a:defRPr>
-            </a:pPr>
-            <a:r>
-              <a:t>Clinical Palette</a:t>
-            </a:r>
-          </a:p>
-          <a:p>
-            <a:pPr>
-              <a:defRPr sz="1050" b="1">
-                <a:solidFill>
-                  <a:srgbClr val="FFFFFF"/>
-                </a:solidFill>
-                <a:latin typeface="Arial"/>
-              </a:defRPr>
-            </a:pPr>
-            <a:r>
-              <a:t>Single-Color #0F6FBF</a:t>
-            </a:r>
-          </a:p>
-          <a:p>
-            <a:pPr>
-              <a:defRPr sz="850">
-                <a:solidFill>
-                  <a:srgbClr val="0EA5E9"/>
-                </a:solidFill>
                 <a:latin typeface="Calibri"/>
               </a:defRPr>
             </a:pPr>
             <a:r>
-              <a:t>WCAG 2.1 AAA Compliant Non-Alarmist Interface</a:t>
+              <a:t>No scary red alert meters; clean, easy-to-read cards</a:t>
             </a:r>
           </a:p>
         </p:txBody>
@@ -3734,8 +3756,8 @@
         </p:nvSpPr>
         <p:spPr>
           <a:xfrm>
-            <a:off x="7406640" y="4151376"/>
-            <a:ext cx="3749039" cy="804672"/>
+            <a:off x="7406640" y="4160520"/>
+            <a:ext cx="3749039" cy="822960"/>
           </a:xfrm>
           <a:prstGeom prst="roundRect">
             <a:avLst/>
@@ -3764,45 +3786,45 @@
           </a:fontRef>
         </p:style>
         <p:txBody>
-          <a:bodyPr rtlCol="0" anchor="ctr" wrap="square" lIns="109728" rIns="109728" tIns="73152"/>
+          <a:bodyPr rtlCol="0" anchor="ctr" wrap="square" lIns="137160" rIns="137160" tIns="73152"/>
           <a:lstStyle/>
           <a:p>
             <a:pPr algn="ctr">
               <a:defRPr sz="950" b="1">
                 <a:solidFill>
+                  <a:srgbClr val="0EA5E9"/>
+                </a:solidFill>
+                <a:latin typeface="Arial"/>
+              </a:defRPr>
+            </a:pPr>
+            <a:r>
+              <a:t>Doctor Standards</a:t>
+            </a:r>
+          </a:p>
+          <a:p>
+            <a:pPr>
+              <a:defRPr sz="1100" b="1">
+                <a:solidFill>
+                  <a:srgbClr val="FFFFFF"/>
+                </a:solidFill>
+                <a:latin typeface="Arial"/>
+              </a:defRPr>
+            </a:pPr>
+            <a:r>
+              <a:t>Real ICD-10 Medical Codes</a:t>
+            </a:r>
+          </a:p>
+          <a:p>
+            <a:pPr>
+              <a:defRPr sz="900">
+                <a:solidFill>
                   <a:srgbClr val="94A3B8"/>
                 </a:solidFill>
-                <a:latin typeface="Arial"/>
-              </a:defRPr>
-            </a:pPr>
-            <a:r>
-              <a:t>Diagnostic Ontology</a:t>
-            </a:r>
-          </a:p>
-          <a:p>
-            <a:pPr>
-              <a:defRPr sz="1050" b="1">
-                <a:solidFill>
-                  <a:srgbClr val="FFFFFF"/>
-                </a:solidFill>
-                <a:latin typeface="Arial"/>
-              </a:defRPr>
-            </a:pPr>
-            <a:r>
-              <a:t>ICD-10-CM Standardized</a:t>
-            </a:r>
-          </a:p>
-          <a:p>
-            <a:pPr>
-              <a:defRPr sz="850">
-                <a:solidFill>
-                  <a:srgbClr val="0EA5E9"/>
-                </a:solidFill>
                 <a:latin typeface="Calibri"/>
               </a:defRPr>
             </a:pPr>
             <a:r>
-              <a:t>L40.0, L20.9, B35.9, L71.0, L03.9 Triage Crosswalk</a:t>
+              <a:t>Uses standard medical codes used by doctors worldwide</a:t>
             </a:r>
           </a:p>
         </p:txBody>
@@ -3815,8 +3837,8 @@
         </p:nvSpPr>
         <p:spPr>
           <a:xfrm>
-            <a:off x="7406640" y="5047488"/>
-            <a:ext cx="3749039" cy="804672"/>
+            <a:off x="7406640" y="5074920"/>
+            <a:ext cx="3749039" cy="822960"/>
           </a:xfrm>
           <a:prstGeom prst="roundRect">
             <a:avLst/>
@@ -3845,45 +3867,45 @@
           </a:fontRef>
         </p:style>
         <p:txBody>
-          <a:bodyPr rtlCol="0" anchor="ctr" wrap="square" lIns="109728" rIns="109728" tIns="73152"/>
+          <a:bodyPr rtlCol="0" anchor="ctr" wrap="square" lIns="137160" rIns="137160" tIns="73152"/>
           <a:lstStyle/>
           <a:p>
             <a:pPr algn="ctr">
               <a:defRPr sz="950" b="1">
                 <a:solidFill>
+                  <a:srgbClr val="0EA5E9"/>
+                </a:solidFill>
+                <a:latin typeface="Arial"/>
+              </a:defRPr>
+            </a:pPr>
+            <a:r>
+              <a:t>100% Private</a:t>
+            </a:r>
+          </a:p>
+          <a:p>
+            <a:pPr>
+              <a:defRPr sz="1100" b="1">
+                <a:solidFill>
+                  <a:srgbClr val="FFFFFF"/>
+                </a:solidFill>
+                <a:latin typeface="Arial"/>
+              </a:defRPr>
+            </a:pPr>
+            <a:r>
+              <a:t>Your Photos Are Never Saved</a:t>
+            </a:r>
+          </a:p>
+          <a:p>
+            <a:pPr>
+              <a:defRPr sz="900">
+                <a:solidFill>
                   <a:srgbClr val="94A3B8"/>
                 </a:solidFill>
-                <a:latin typeface="Arial"/>
-              </a:defRPr>
-            </a:pPr>
-            <a:r>
-              <a:t>Privacy Architecture</a:t>
-            </a:r>
-          </a:p>
-          <a:p>
-            <a:pPr>
-              <a:defRPr sz="1050" b="1">
-                <a:solidFill>
-                  <a:srgbClr val="FFFFFF"/>
-                </a:solidFill>
-                <a:latin typeface="Arial"/>
-              </a:defRPr>
-            </a:pPr>
-            <a:r>
-              <a:t>Zero-Telemetry Local</a:t>
-            </a:r>
-          </a:p>
-          <a:p>
-            <a:pPr>
-              <a:defRPr sz="850">
-                <a:solidFill>
-                  <a:srgbClr val="0EA5E9"/>
-                </a:solidFill>
                 <a:latin typeface="Calibri"/>
               </a:defRPr>
             </a:pPr>
             <a:r>
-              <a:t>In-Memory Image Processing &amp; Local Session Store</a:t>
+              <a:t>Everything stays in your device memory; zero cloud storage</a:t>
             </a:r>
           </a:p>
         </p:txBody>
@@ -3923,7 +3945,7 @@
         <p:spPr>
           <a:xfrm>
             <a:off x="731520" y="365760"/>
-            <a:ext cx="10698480" cy="320040"/>
+            <a:ext cx="10698480" cy="292608"/>
           </a:xfrm>
           <a:prstGeom prst="rect">
             <a:avLst/>
@@ -3945,7 +3967,7 @@
               </a:defRPr>
             </a:pPr>
             <a:r>
-              <a:t>DERMOSCAN AI WORKSTATION</a:t>
+              <a:t>DERMOSCAN AI ASSISTANT</a:t>
             </a:r>
           </a:p>
         </p:txBody>
@@ -3981,7 +4003,7 @@
               </a:defRPr>
             </a:pPr>
             <a:r>
-              <a:t>Technology Stack Matrix &amp; Performance Engineering</a:t>
+              <a:t>Modern Tools Built for Speed and Simplicity</a:t>
             </a:r>
           </a:p>
         </p:txBody>
@@ -4009,7 +4031,7 @@
           <a:lstStyle/>
           <a:p>
             <a:pPr>
-              <a:defRPr sz="1250">
+              <a:defRPr sz="1300">
                 <a:solidFill>
                   <a:srgbClr val="475569"/>
                 </a:solidFill>
@@ -4017,7 +4039,7 @@
               </a:defRPr>
             </a:pPr>
             <a:r>
-              <a:t>Modern TypeScript web ecosystem built for sub-second clinical triage execution.</a:t>
+              <a:t>Built with the latest reliable web tools so it runs smoothly on any smartphone or computer.</a:t>
             </a:r>
           </a:p>
         </p:txBody>
@@ -4109,7 +4131,7 @@
           <a:lstStyle/>
           <a:p>
             <a:pPr algn="ctr">
-              <a:defRPr sz="950" b="1">
+              <a:defRPr sz="1000" b="1">
                 <a:solidFill>
                   <a:srgbClr val="0F6FBF"/>
                 </a:solidFill>
@@ -4117,12 +4139,12 @@
               </a:defRPr>
             </a:pPr>
             <a:r>
-              <a:t>Frontend Framework</a:t>
-            </a:r>
-          </a:p>
-          <a:p>
-            <a:pPr>
-              <a:defRPr sz="1000">
+              <a:t>React 18</a:t>
+            </a:r>
+          </a:p>
+          <a:p>
+            <a:pPr>
+              <a:defRPr sz="950">
                 <a:solidFill>
                   <a:srgbClr val="0F172A"/>
                 </a:solidFill>
@@ -4130,7 +4152,7 @@
               </a:defRPr>
             </a:pPr>
             <a:r>
-              <a:t>React 18.3 (Component-driven architecture)</a:t>
+              <a:t>Builds a smooth, interactive website with zero page reloads</a:t>
             </a:r>
           </a:p>
         </p:txBody>
@@ -4177,7 +4199,7 @@
           <a:lstStyle/>
           <a:p>
             <a:pPr algn="ctr">
-              <a:defRPr sz="950" b="1">
+              <a:defRPr sz="1000" b="1">
                 <a:solidFill>
                   <a:srgbClr val="0F6FBF"/>
                 </a:solidFill>
@@ -4185,12 +4207,12 @@
               </a:defRPr>
             </a:pPr>
             <a:r>
-              <a:t>Programming Language</a:t>
-            </a:r>
-          </a:p>
-          <a:p>
-            <a:pPr>
-              <a:defRPr sz="1000">
+              <a:t>TypeScript 5.7</a:t>
+            </a:r>
+          </a:p>
+          <a:p>
+            <a:pPr>
+              <a:defRPr sz="950">
                 <a:solidFill>
                   <a:srgbClr val="0F172A"/>
                 </a:solidFill>
@@ -4198,7 +4220,7 @@
               </a:defRPr>
             </a:pPr>
             <a:r>
-              <a:t>TypeScript 5.7 (Strict static typing &amp; clinical schemas)</a:t>
+              <a:t>Prevents bugs and ensures all medical data is handled correctly</a:t>
             </a:r>
           </a:p>
         </p:txBody>
@@ -4245,7 +4267,7 @@
           <a:lstStyle/>
           <a:p>
             <a:pPr algn="ctr">
-              <a:defRPr sz="950" b="1">
+              <a:defRPr sz="1000" b="1">
                 <a:solidFill>
                   <a:srgbClr val="0F6FBF"/>
                 </a:solidFill>
@@ -4253,12 +4275,12 @@
               </a:defRPr>
             </a:pPr>
             <a:r>
-              <a:t>Build Tooling</a:t>
-            </a:r>
-          </a:p>
-          <a:p>
-            <a:pPr>
-              <a:defRPr sz="1000">
+              <a:t>Vite 6</a:t>
+            </a:r>
+          </a:p>
+          <a:p>
+            <a:pPr>
+              <a:defRPr sz="950">
                 <a:solidFill>
                   <a:srgbClr val="0F172A"/>
                 </a:solidFill>
@@ -4266,7 +4288,7 @@
               </a:defRPr>
             </a:pPr>
             <a:r>
-              <a:t>Vite 6 (ESM instant hot-reload &amp; tree-shaking)</a:t>
+              <a:t>Ultra-fast modern development tool for instant loading</a:t>
             </a:r>
           </a:p>
         </p:txBody>
@@ -4313,7 +4335,7 @@
           <a:lstStyle/>
           <a:p>
             <a:pPr algn="ctr">
-              <a:defRPr sz="950" b="1">
+              <a:defRPr sz="1000" b="1">
                 <a:solidFill>
                   <a:srgbClr val="0F6FBF"/>
                 </a:solidFill>
@@ -4321,12 +4343,12 @@
               </a:defRPr>
             </a:pPr>
             <a:r>
-              <a:t>Styling System</a:t>
-            </a:r>
-          </a:p>
-          <a:p>
-            <a:pPr>
-              <a:defRPr sz="1000">
+              <a:t>Tailwind CSS</a:t>
+            </a:r>
+          </a:p>
+          <a:p>
+            <a:pPr>
+              <a:defRPr sz="950">
                 <a:solidFill>
                   <a:srgbClr val="0F172A"/>
                 </a:solidFill>
@@ -4334,7 +4356,7 @@
               </a:defRPr>
             </a:pPr>
             <a:r>
-              <a:t>Tailwind CSS 3.4 (Single-color #0F6FBF WCAG AAA tokens)</a:t>
+              <a:t>Creates a clean, simple look that adjusts to any screen size</a:t>
             </a:r>
           </a:p>
         </p:txBody>
@@ -4381,7 +4403,7 @@
           <a:lstStyle/>
           <a:p>
             <a:pPr algn="ctr">
-              <a:defRPr sz="950" b="1">
+              <a:defRPr sz="1000" b="1">
                 <a:solidFill>
                   <a:srgbClr val="0F6FBF"/>
                 </a:solidFill>
@@ -4389,12 +4411,12 @@
               </a:defRPr>
             </a:pPr>
             <a:r>
-              <a:t>Optical Processing</a:t>
-            </a:r>
-          </a:p>
-          <a:p>
-            <a:pPr>
-              <a:defRPr sz="1000">
+              <a:t>HTML5 Canvas</a:t>
+            </a:r>
+          </a:p>
+          <a:p>
+            <a:pPr>
+              <a:defRPr sz="950">
                 <a:solidFill>
                   <a:srgbClr val="0F172A"/>
                 </a:solidFill>
@@ -4402,7 +4424,7 @@
               </a:defRPr>
             </a:pPr>
             <a:r>
-              <a:t>HTML5 2D Canvas API (Bilinear interpolation)</a:t>
+              <a:t>Resizes heavy phone photos directly inside the browser</a:t>
             </a:r>
           </a:p>
         </p:txBody>
@@ -4449,7 +4471,7 @@
           <a:lstStyle/>
           <a:p>
             <a:pPr algn="ctr">
-              <a:defRPr sz="950" b="1">
+              <a:defRPr sz="1000" b="1">
                 <a:solidFill>
                   <a:srgbClr val="0F6FBF"/>
                 </a:solidFill>
@@ -4457,12 +4479,12 @@
               </a:defRPr>
             </a:pPr>
             <a:r>
-              <a:t>Iconography</a:t>
-            </a:r>
-          </a:p>
-          <a:p>
-            <a:pPr>
-              <a:defRPr sz="1000">
+              <a:t>Lucide Icons</a:t>
+            </a:r>
+          </a:p>
+          <a:p>
+            <a:pPr>
+              <a:defRPr sz="950">
                 <a:solidFill>
                   <a:srgbClr val="0F172A"/>
                 </a:solidFill>
@@ -4470,7 +4492,7 @@
               </a:defRPr>
             </a:pPr>
             <a:r>
-              <a:t>Lucide React (Clinical vector symbols)</a:t>
+              <a:t>Clear, friendly medical and navigation icons</a:t>
             </a:r>
           </a:p>
         </p:txBody>
@@ -4517,7 +4539,7 @@
           <a:lstStyle/>
           <a:p>
             <a:pPr algn="ctr">
-              <a:defRPr sz="950" b="1">
+              <a:defRPr sz="1000" b="1">
                 <a:solidFill>
                   <a:srgbClr val="0F6FBF"/>
                 </a:solidFill>
@@ -4525,12 +4547,12 @@
               </a:defRPr>
             </a:pPr>
             <a:r>
-              <a:t>Deployment &amp; Edge</a:t>
-            </a:r>
-          </a:p>
-          <a:p>
-            <a:pPr>
-              <a:defRPr sz="1000">
+              <a:t>Vercel Hosting</a:t>
+            </a:r>
+          </a:p>
+          <a:p>
+            <a:pPr>
+              <a:defRPr sz="950">
                 <a:solidFill>
                   <a:srgbClr val="0F172A"/>
                 </a:solidFill>
@@ -4538,7 +4560,7 @@
               </a:defRPr>
             </a:pPr>
             <a:r>
-              <a:t>Vercel Edge Global CDN (dermo-scan-nesn.vercel.app)</a:t>
+              <a:t>Hosts the app online so anyone in the world can access it for free</a:t>
             </a:r>
           </a:p>
         </p:txBody>
@@ -4593,7 +4615,7 @@
               </a:defRPr>
             </a:pPr>
             <a:r>
-              <a:t>Sub-800ms Edge Latency</a:t>
+              <a:t>Super Fast (Under 1 Second)</a:t>
             </a:r>
           </a:p>
           <a:p>
@@ -4601,7 +4623,7 @@
               <a:spcBef>
                 <a:spcPts val="200"/>
               </a:spcBef>
-              <a:defRPr sz="950">
+              <a:defRPr sz="1000">
                 <a:solidFill>
                   <a:srgbClr val="0F172A"/>
                 </a:solidFill>
@@ -4609,7 +4631,7 @@
               </a:defRPr>
             </a:pPr>
             <a:r>
-              <a:t>Client-side canvas scaling eliminates network bottleneck. Payload payload size is reduced from 15MB to under 250KB before transmission.</a:t>
+              <a:t>Resizing images right on your device reduces file size from 15MB to under 250KB, making scans almost instant.</a:t>
             </a:r>
           </a:p>
         </p:txBody>
@@ -4664,7 +4686,7 @@
               </a:defRPr>
             </a:pPr>
             <a:r>
-              <a:t>WCAG 2.1 AAA Single-Color System</a:t>
+              <a:t>Calm Medical Blue Design</a:t>
             </a:r>
           </a:p>
           <a:p>
@@ -4672,7 +4694,7 @@
               <a:spcBef>
                 <a:spcPts val="200"/>
               </a:spcBef>
-              <a:defRPr sz="950">
+              <a:defRPr sz="1000">
                 <a:solidFill>
                   <a:srgbClr val="0F172A"/>
                 </a:solidFill>
@@ -4680,7 +4702,7 @@
               </a:defRPr>
             </a:pPr>
             <a:r>
-              <a:t>Eliminated red/amber/green traffic-light meters to avoid cognitive fatigue and prevent misinterpretation by color-vision deficient clinicians.</a:t>
+              <a:t>We purposely removed harsh red and yellow warning lights to reduce patient anxiety and make it easy to read.</a:t>
             </a:r>
           </a:p>
         </p:txBody>
@@ -4735,7 +4757,7 @@
               </a:defRPr>
             </a:pPr>
             <a:r>
-              <a:t>Schema-Compliant Type Safety</a:t>
+              <a:t>Works on Phones and Laptops</a:t>
             </a:r>
           </a:p>
           <a:p>
@@ -4743,7 +4765,7 @@
               <a:spcBef>
                 <a:spcPts val="200"/>
               </a:spcBef>
-              <a:defRPr sz="950">
+              <a:defRPr sz="1000">
                 <a:solidFill>
                   <a:srgbClr val="0F172A"/>
                 </a:solidFill>
@@ -4751,7 +4773,7 @@
               </a:defRPr>
             </a:pPr>
             <a:r>
-              <a:t>Strict TypeScript interfaces enforce exact property validation for ICD codes, confidence scores, and morphology matrices.</a:t>
+              <a:t>Whether you open it on an Android phone, iPhone, tablet, or PC, the layout adjusts automatically.</a:t>
             </a:r>
           </a:p>
         </p:txBody>
@@ -4806,7 +4828,7 @@
               </a:defRPr>
             </a:pPr>
             <a:r>
-              <a:t>Deterministic Rule-Based Fallback</a:t>
+              <a:t>Reliable Even Offline</a:t>
             </a:r>
           </a:p>
           <a:p>
@@ -4814,7 +4836,7 @@
               <a:spcBef>
                 <a:spcPts val="200"/>
               </a:spcBef>
-              <a:defRPr sz="950">
+              <a:defRPr sz="1000">
                 <a:solidFill>
                   <a:srgbClr val="0F172A"/>
                 </a:solidFill>
@@ -4822,7 +4844,7 @@
               </a:defRPr>
             </a:pPr>
             <a:r>
-              <a:t>Zero downtime architecture: if connectivity drops, offline clinical decision trees maintain triage availability at remote primary clinics.</a:t>
+              <a:t>Has built-in fallback rules so the triage system keeps working even if the internet connection is weak.</a:t>
             </a:r>
           </a:p>
         </p:txBody>
@@ -4862,7 +4884,7 @@
         <p:spPr>
           <a:xfrm>
             <a:off x="731520" y="365760"/>
-            <a:ext cx="10698480" cy="320040"/>
+            <a:ext cx="10698480" cy="292608"/>
           </a:xfrm>
           <a:prstGeom prst="rect">
             <a:avLst/>
@@ -4884,7 +4906,7 @@
               </a:defRPr>
             </a:pPr>
             <a:r>
-              <a:t>DERMOSCAN AI WORKSTATION</a:t>
+              <a:t>DERMOSCAN AI ASSISTANT</a:t>
             </a:r>
           </a:p>
         </p:txBody>
@@ -4920,7 +4942,7 @@
               </a:defRPr>
             </a:pPr>
             <a:r>
-              <a:t>Clinical Safety Protocols &amp; Medical Governance</a:t>
+              <a:t>Safety First: Clear Rules and Ethical Safeguards</a:t>
             </a:r>
           </a:p>
         </p:txBody>
@@ -4948,7 +4970,7 @@
           <a:lstStyle/>
           <a:p>
             <a:pPr>
-              <a:defRPr sz="1250">
+              <a:defRPr sz="1300">
                 <a:solidFill>
                   <a:srgbClr val="475569"/>
                 </a:solidFill>
@@ -4956,7 +4978,7 @@
               </a:defRPr>
             </a:pPr>
             <a:r>
-              <a:t>DermoScan is engineered strictly as decision support, enforcing strict safety guardrails.</a:t>
+              <a:t>DermoScan is built to assist and guide, never to replace your doctor.</a:t>
             </a:r>
           </a:p>
         </p:txBody>
@@ -5092,7 +5114,7 @@
               </a:defRPr>
             </a:pPr>
             <a:r>
-              <a:t>Triage-Only Gatekeeper</a:t>
+              <a:t>Helper, Not a Doctor</a:t>
             </a:r>
           </a:p>
           <a:p>
@@ -5111,12 +5133,12 @@
               </a:defRPr>
             </a:pPr>
             <a:r>
-              <a:t>Physician-in-the-Loop Validation</a:t>
-            </a:r>
-          </a:p>
-          <a:p>
-            <a:pPr>
-              <a:defRPr sz="1050">
+              <a:t>Always See a Doctor</a:t>
+            </a:r>
+          </a:p>
+          <a:p>
+            <a:pPr>
+              <a:defRPr sz="1100">
                 <a:solidFill>
                   <a:srgbClr val="475569"/>
                 </a:solidFill>
@@ -5124,7 +5146,7 @@
               </a:defRPr>
             </a:pPr>
             <a:r>
-              <a:t>Stratifies risk tiers (Routine, Expedited, Urgent) to prioritize clinical queues rather than generating unilateral automated diagnoses.</a:t>
+              <a:t>It gives helpful guidance and information, but always reminds users that only a licensed doctor can give a final medical diagnosis.</a:t>
             </a:r>
           </a:p>
         </p:txBody>
@@ -5260,7 +5282,7 @@
               </a:defRPr>
             </a:pPr>
             <a:r>
-              <a:t>Non-Skin Rejection Filter</a:t>
+              <a:t>Rejects Blurry Photos</a:t>
             </a:r>
           </a:p>
           <a:p>
@@ -5279,12 +5301,12 @@
               </a:defRPr>
             </a:pPr>
             <a:r>
-              <a:t>Optical Specimen Integrity</a:t>
-            </a:r>
-          </a:p>
-          <a:p>
-            <a:pPr>
-              <a:defRPr sz="1050">
+              <a:t>Quality Image Check</a:t>
+            </a:r>
+          </a:p>
+          <a:p>
+            <a:pPr>
+              <a:defRPr sz="1100">
                 <a:solidFill>
                   <a:srgbClr val="475569"/>
                 </a:solidFill>
@@ -5292,7 +5314,7 @@
               </a:defRPr>
             </a:pPr>
             <a:r>
-              <a:t>Integrated quality filter detects low-resolution, blurred, or non-cutaneous images, rejecting corrupt specimens prior to inference.</a:t>
+              <a:t>If a photo is too blurry, too dark, or doesn't show skin, it asks you to take a clearer photo instead of guessing blindly.</a:t>
             </a:r>
           </a:p>
         </p:txBody>
@@ -5428,7 +5450,7 @@
               </a:defRPr>
             </a:pPr>
             <a:r>
-              <a:t>Emergency Escalation Protocol</a:t>
+              <a:t>Emergency Alerts</a:t>
             </a:r>
           </a:p>
           <a:p>
@@ -5447,12 +5469,12 @@
               </a:defRPr>
             </a:pPr>
             <a:r>
-              <a:t>Rapid Emergency Triage Referral</a:t>
-            </a:r>
-          </a:p>
-          <a:p>
-            <a:pPr>
-              <a:defRPr sz="1050">
+              <a:t>Fast Emergency Warning</a:t>
+            </a:r>
+          </a:p>
+          <a:p>
+            <a:pPr>
+              <a:defRPr sz="1100">
                 <a:solidFill>
                   <a:srgbClr val="475569"/>
                 </a:solidFill>
@@ -5460,7 +5482,7 @@
               </a:defRPr>
             </a:pPr>
             <a:r>
-              <a:t>Automatic alert banners triggered for suspected acute cellulitis (L03.9) or malignant melanoma indicators (ABCDE criteria).</a:t>
+              <a:t>If signs indicate a fast-spreading severe infection (like Cellulitis), it displays an immediate warning to visit a hospital.</a:t>
             </a:r>
           </a:p>
         </p:txBody>
@@ -5596,7 +5618,7 @@
               </a:defRPr>
             </a:pPr>
             <a:r>
-              <a:t>Steroid Misuse Safeguard</a:t>
+              <a:t>Stops Wrong Cream Misuse</a:t>
             </a:r>
           </a:p>
           <a:p>
@@ -5615,12 +5637,12 @@
               </a:defRPr>
             </a:pPr>
             <a:r>
-              <a:t>Tinea Incognito Prevention</a:t>
-            </a:r>
-          </a:p>
-          <a:p>
-            <a:pPr>
-              <a:defRPr sz="1050">
+              <a:t>Prevents Self-Harm</a:t>
+            </a:r>
+          </a:p>
+          <a:p>
+            <a:pPr>
+              <a:defRPr sz="1100">
                 <a:solidFill>
                   <a:srgbClr val="475569"/>
                 </a:solidFill>
@@ -5628,7 +5650,7 @@
               </a:defRPr>
             </a:pPr>
             <a:r>
-              <a:t>Explicit contraindications warn against topical corticosteroids on annular scaly lesions until dermatophyte fungal scrape is ruled out.</a:t>
+              <a:t>Explicitly warns against applying steroid creams to ringworm or fungal infections, preventing dangerous skin damage.</a:t>
             </a:r>
           </a:p>
         </p:txBody>
@@ -5675,7 +5697,7 @@
           <a:lstStyle/>
           <a:p>
             <a:pPr algn="ctr">
-              <a:defRPr sz="1050" b="1">
+              <a:defRPr sz="1100" b="1">
                 <a:solidFill>
                   <a:srgbClr val="0F172A"/>
                 </a:solidFill>
@@ -5683,7 +5705,7 @@
               </a:defRPr>
             </a:pPr>
             <a:r>
-              <a:t>Clinical Governance Mandate: DermoScan does not replace clinical judgment; all recommendations require confirmation by a licensed physician.</a:t>
+              <a:t>Golden Rule: DermoScan is a helpful guide. Never start prescription medicine without seeing a doctor first.</a:t>
             </a:r>
           </a:p>
         </p:txBody>
@@ -5723,7 +5745,7 @@
         <p:spPr>
           <a:xfrm>
             <a:off x="731520" y="365760"/>
-            <a:ext cx="10698480" cy="320040"/>
+            <a:ext cx="10698480" cy="292608"/>
           </a:xfrm>
           <a:prstGeom prst="rect">
             <a:avLst/>
@@ -5745,7 +5767,7 @@
               </a:defRPr>
             </a:pPr>
             <a:r>
-              <a:t>DERMOSCAN AI WORKSTATION</a:t>
+              <a:t>DERMOSCAN AI ASSISTANT</a:t>
             </a:r>
           </a:p>
         </p:txBody>
@@ -5781,7 +5803,7 @@
               </a:defRPr>
             </a:pPr>
             <a:r>
-              <a:t>Engineering Challenges Faced &amp; Technical Solutions</a:t>
+              <a:t>Problems We Faced and How We Solved Them</a:t>
             </a:r>
           </a:p>
         </p:txBody>
@@ -5809,7 +5831,7 @@
           <a:lstStyle/>
           <a:p>
             <a:pPr>
-              <a:defRPr sz="1250">
+              <a:defRPr sz="1300">
                 <a:solidFill>
                   <a:srgbClr val="475569"/>
                 </a:solidFill>
@@ -5817,7 +5839,7 @@
               </a:defRPr>
             </a:pPr>
             <a:r>
-              <a:t>Addressing real-world constraints in client-side imaging, accessibility, and AI reliability.</a:t>
+              <a:t>Every real project faces challenges. Here is how we tackled each one simply and smartly.</a:t>
             </a:r>
           </a:p>
         </p:txBody>
@@ -5890,7 +5912,7 @@
           <a:lstStyle/>
           <a:p>
             <a:pPr>
-              <a:defRPr sz="1100" b="1">
+              <a:defRPr sz="1150" b="1">
                 <a:solidFill>
                   <a:srgbClr val="0F172A"/>
                 </a:solidFill>
@@ -5898,7 +5920,7 @@
               </a:defRPr>
             </a:pPr>
             <a:r>
-              <a:t>Challenge 1: High-Resolution Camera Payloads</a:t>
+              <a:t>Challenge 1: Big phone photos were too slow to upload</a:t>
             </a:r>
           </a:p>
           <a:p>
@@ -5907,9 +5929,9 @@
                 <a:spcPts val="200"/>
               </a:spcBef>
               <a:spcAft>
-                <a:spcPts val="500"/>
+                <a:spcPts val="400"/>
               </a:spcAft>
-              <a:defRPr sz="950">
+              <a:defRPr sz="1000">
                 <a:solidFill>
                   <a:srgbClr val="475569"/>
                 </a:solidFill>
@@ -5917,7 +5939,7 @@
               </a:defRPr>
             </a:pPr>
             <a:r>
-              <a:t>Modern smartphone cameras generate 15MB+ raw files, exceeding edge serverless body limits and stalling mobile networks.</a:t>
+              <a:t>Modern smartphones take 15MB photos. Uploading them on slow mobile connections took forever and caused errors.</a:t>
             </a:r>
           </a:p>
           <a:p>
@@ -5930,7 +5952,7 @@
               </a:defRPr>
             </a:pPr>
             <a:r>
-              <a:t>Solution: HTML5 Canvas 2D Downsampler</a:t>
+              <a:t>Solution: Auto-Resize Inside Browser</a:t>
             </a:r>
           </a:p>
           <a:p>
@@ -5938,7 +5960,7 @@
               <a:spcBef>
                 <a:spcPts val="200"/>
               </a:spcBef>
-              <a:defRPr sz="950">
+              <a:defRPr sz="1000">
                 <a:solidFill>
                   <a:srgbClr val="0F172A"/>
                 </a:solidFill>
@@ -5946,7 +5968,7 @@
               </a:defRPr>
             </a:pPr>
             <a:r>
-              <a:t>Engineered client-side canvas downsampling constrained to max 1024px while retaining pathognomonic scaling micro-textures.</a:t>
+              <a:t>We added browser-based resizing that shrinks the photo to a lightweight size in milliseconds before sending.</a:t>
             </a:r>
           </a:p>
         </p:txBody>
@@ -6019,7 +6041,7 @@
           <a:lstStyle/>
           <a:p>
             <a:pPr>
-              <a:defRPr sz="1100" b="1">
+              <a:defRPr sz="1150" b="1">
                 <a:solidFill>
                   <a:srgbClr val="0F172A"/>
                 </a:solidFill>
@@ -6027,7 +6049,7 @@
               </a:defRPr>
             </a:pPr>
             <a:r>
-              <a:t>Challenge 2: Multi-Color Alarmism in Clinical UIs</a:t>
+              <a:t>Challenge 2: Red warning meters scare patients</a:t>
             </a:r>
           </a:p>
           <a:p>
@@ -6036,9 +6058,9 @@
                 <a:spcPts val="200"/>
               </a:spcBef>
               <a:spcAft>
-                <a:spcPts val="500"/>
+                <a:spcPts val="400"/>
               </a:spcAft>
-              <a:defRPr sz="950">
+              <a:defRPr sz="1000">
                 <a:solidFill>
                   <a:srgbClr val="475569"/>
                 </a:solidFill>
@@ -6046,7 +6068,7 @@
               </a:defRPr>
             </a:pPr>
             <a:r>
-              <a:t>Conventional red/amber/green meters induce patient anxiety and confuse clinicians with deuteranopia color blindness.</a:t>
+              <a:t>Traditional healthcare apps use bright red, yellow, and green meters that make users panic unnecessarily.</a:t>
             </a:r>
           </a:p>
           <a:p>
@@ -6059,7 +6081,7 @@
               </a:defRPr>
             </a:pPr>
             <a:r>
-              <a:t>Solution: Single-Color #0F6FBF Clinical Palette</a:t>
+              <a:t>Solution: Calm Medical Blue Theme</a:t>
             </a:r>
           </a:p>
           <a:p>
@@ -6067,7 +6089,7 @@
               <a:spcBef>
                 <a:spcPts val="200"/>
               </a:spcBef>
-              <a:defRPr sz="950">
+              <a:defRPr sz="1000">
                 <a:solidFill>
                   <a:srgbClr val="0F172A"/>
                 </a:solidFill>
@@ -6075,7 +6097,7 @@
               </a:defRPr>
             </a:pPr>
             <a:r>
-              <a:t>Standardized on WCAG 2.1 AAA medical blue (#0F6FBF) using typographic weight and percentage meters for calm clinical clarity.</a:t>
+              <a:t>We switched to a clean, calm medical blue (#0F6FBF) palette that shows facts clearly without causing alarm.</a:t>
             </a:r>
           </a:p>
         </p:txBody>
@@ -6148,7 +6170,7 @@
           <a:lstStyle/>
           <a:p>
             <a:pPr>
-              <a:defRPr sz="1100" b="1">
+              <a:defRPr sz="1150" b="1">
                 <a:solidFill>
                   <a:srgbClr val="0F172A"/>
                 </a:solidFill>
@@ -6156,7 +6178,7 @@
               </a:defRPr>
             </a:pPr>
             <a:r>
-              <a:t>Challenge 3: Vision AI Schema Drift</a:t>
+              <a:t>Challenge 3: AI models sometimes return messy text</a:t>
             </a:r>
           </a:p>
           <a:p>
@@ -6165,9 +6187,9 @@
                 <a:spcPts val="200"/>
               </a:spcBef>
               <a:spcAft>
-                <a:spcPts val="500"/>
+                <a:spcPts val="400"/>
               </a:spcAft>
-              <a:defRPr sz="950">
+              <a:defRPr sz="1000">
                 <a:solidFill>
                   <a:srgbClr val="475569"/>
                 </a:solidFill>
@@ -6175,7 +6197,7 @@
               </a:defRPr>
             </a:pPr>
             <a:r>
-              <a:t>Multimodal foundation models occasionally return markdown wrappers or hallucinated keys instead of valid JSON payloads.</a:t>
+              <a:t>AI models sometimes add extra symbols or unpredictable wording instead of clean structured answers.</a:t>
             </a:r>
           </a:p>
           <a:p>
@@ -6188,7 +6210,7 @@
               </a:defRPr>
             </a:pPr>
             <a:r>
-              <a:t>Solution: Regex-Based JSON Extraction Pipeline</a:t>
+              <a:t>Solution: Smart Text Cleaning Filters</a:t>
             </a:r>
           </a:p>
           <a:p>
@@ -6196,7 +6218,7 @@
               <a:spcBef>
                 <a:spcPts val="200"/>
               </a:spcBef>
-              <a:defRPr sz="950">
+              <a:defRPr sz="1000">
                 <a:solidFill>
                   <a:srgbClr val="0F172A"/>
                 </a:solidFill>
@@ -6204,7 +6226,7 @@
               </a:defRPr>
             </a:pPr>
             <a:r>
-              <a:t>Implemented regex-based sanitization that isolates JSON objects and strictly validates fields against TypeScript clinical types.</a:t>
+              <a:t>We wrote automated filters that clean the AI answer and format it neatly into the exact same boxes every time.</a:t>
             </a:r>
           </a:p>
         </p:txBody>
@@ -6277,7 +6299,7 @@
           <a:lstStyle/>
           <a:p>
             <a:pPr>
-              <a:defRPr sz="1100" b="1">
+              <a:defRPr sz="1150" b="1">
                 <a:solidFill>
                   <a:srgbClr val="0F172A"/>
                 </a:solidFill>
@@ -6285,7 +6307,7 @@
               </a:defRPr>
             </a:pPr>
             <a:r>
-              <a:t>Challenge 4: Phototype Diagnostic Bias</a:t>
+              <a:t>Challenge 4: Redness is hard to see on brown skin</a:t>
             </a:r>
           </a:p>
           <a:p>
@@ -6294,9 +6316,9 @@
                 <a:spcPts val="200"/>
               </a:spcBef>
               <a:spcAft>
-                <a:spcPts val="500"/>
+                <a:spcPts val="400"/>
               </a:spcAft>
-              <a:defRPr sz="950">
+              <a:defRPr sz="1000">
                 <a:solidFill>
                   <a:srgbClr val="475569"/>
                 </a:solidFill>
@@ -6304,7 +6326,7 @@
               </a:defRPr>
             </a:pPr>
             <a:r>
-              <a:t>Darker skin phototypes (Fitzpatrick IV–VI) often mask erythema, causing lower confidence on purely visual classifiers.</a:t>
+              <a:t>Red skin rashes do not show up brightly on darker Indian and African skin tones, confusing visual-only AI.</a:t>
             </a:r>
           </a:p>
           <a:p>
@@ -6317,7 +6339,7 @@
               </a:defRPr>
             </a:pPr>
             <a:r>
-              <a:t>Solution: Multi-Factor Clinical Weighting</a:t>
+              <a:t>Solution: Asking Questions About Symptoms</a:t>
             </a:r>
           </a:p>
           <a:p>
@@ -6325,7 +6347,7 @@
               <a:spcBef>
                 <a:spcPts val="200"/>
               </a:spcBef>
-              <a:defRPr sz="950">
+              <a:defRPr sz="1000">
                 <a:solidFill>
                   <a:srgbClr val="0F172A"/>
                 </a:solidFill>
@@ -6333,7 +6355,7 @@
               </a:defRPr>
             </a:pPr>
             <a:r>
-              <a:t>Weighted anatomical body site, chronicity, and pruritus sensation metadata alongside image hue to equalize diagnostic confidence.</a:t>
+              <a:t>We asked patients where it is, how long they have had it, and how it feels, so the AI doesn't rely on color alone.</a:t>
             </a:r>
           </a:p>
         </p:txBody>
@@ -6373,7 +6395,7 @@
         <p:spPr>
           <a:xfrm>
             <a:off x="731520" y="365760"/>
-            <a:ext cx="10698480" cy="320040"/>
+            <a:ext cx="10698480" cy="292608"/>
           </a:xfrm>
           <a:prstGeom prst="rect">
             <a:avLst/>
@@ -6395,7 +6417,7 @@
               </a:defRPr>
             </a:pPr>
             <a:r>
-              <a:t>DERMOSCAN AI WORKSTATION</a:t>
+              <a:t>DERMOSCAN AI ASSISTANT</a:t>
             </a:r>
           </a:p>
         </p:txBody>
@@ -6431,7 +6453,7 @@
               </a:defRPr>
             </a:pPr>
             <a:r>
-              <a:t>What Comes Next: Future Roadmap &amp; Project Conclusion</a:t>
+              <a:t>What Comes Next &amp; Project Conclusion</a:t>
             </a:r>
           </a:p>
         </p:txBody>
@@ -6459,7 +6481,7 @@
           <a:lstStyle/>
           <a:p>
             <a:pPr>
-              <a:defRPr sz="1250">
+              <a:defRPr sz="1300">
                 <a:solidFill>
                   <a:srgbClr val="94A3B8"/>
                 </a:solidFill>
@@ -6467,7 +6489,7 @@
               </a:defRPr>
             </a:pPr>
             <a:r>
-              <a:t>Advancing on-device intelligence, spectrophotometry, and hospital EHR interoperability.</a:t>
+              <a:t>Future improvements to make skin checks accessible to everyone across India.</a:t>
             </a:r>
           </a:p>
         </p:txBody>
@@ -6522,7 +6544,7 @@
               </a:defRPr>
             </a:pPr>
             <a:r>
-              <a:t>On-Device MobileNetV4</a:t>
+              <a:t>Offline Mobile App</a:t>
             </a:r>
           </a:p>
           <a:p>
@@ -6538,7 +6560,7 @@
               </a:defRPr>
             </a:pPr>
             <a:r>
-              <a:t>Edge WebAssembly CNN model for 100% offline triage in remote clinics.</a:t>
+              <a:t>A lightweight phone app that works completely offline without any internet connection.</a:t>
             </a:r>
           </a:p>
         </p:txBody>
@@ -6593,7 +6615,7 @@
               </a:defRPr>
             </a:pPr>
             <a:r>
-              <a:t>ITA° Phototype Spectrophotometry</a:t>
+              <a:t>Better Indian Skin Calibration</a:t>
             </a:r>
           </a:p>
           <a:p>
@@ -6609,7 +6631,7 @@
               </a:defRPr>
             </a:pPr>
             <a:r>
-              <a:t>Individual Typology Angle skin calibration for melanin-equitable scoring.</a:t>
+              <a:t>Special color tuning to better detect rashes on brown and deeper skin tones.</a:t>
             </a:r>
           </a:p>
         </p:txBody>
@@ -6664,7 +6686,7 @@
               </a:defRPr>
             </a:pPr>
             <a:r>
-              <a:t>HL7 / FHIR Interoperability</a:t>
+              <a:t>Direct Hospital PDF Export</a:t>
             </a:r>
           </a:p>
           <a:p>
@@ -6680,7 +6702,7 @@
               </a:defRPr>
             </a:pPr>
             <a:r>
-              <a:t>Exporting standardized JSON clinical dossiers into hospital EHR systems.</a:t>
+              <a:t>Download a 1-page PDF summary to show directly to your clinic or family doctor.</a:t>
             </a:r>
           </a:p>
         </p:txBody>
@@ -6735,7 +6757,7 @@
               </a:defRPr>
             </a:pPr>
             <a:r>
-              <a:t>Dermoscopy Lens Integration</a:t>
+              <a:t>Pocket Lens Support</a:t>
             </a:r>
           </a:p>
           <a:p>
@@ -6751,7 +6773,7 @@
               </a:defRPr>
             </a:pPr>
             <a:r>
-              <a:t>Polarized magnification support for sub-epidermal melanocytic analysis.</a:t>
+              <a:t>Support for low-cost dermatoscope magnifying lenses attached to phone cameras.</a:t>
             </a:r>
           </a:p>
         </p:txBody>
@@ -6806,7 +6828,7 @@
               </a:defRPr>
             </a:pPr>
             <a:r>
-              <a:t>Multilingual Clinical Voice</a:t>
+              <a:t>Indian Regional Languages</a:t>
             </a:r>
           </a:p>
           <a:p>
@@ -6822,7 +6844,7 @@
               </a:defRPr>
             </a:pPr>
             <a:r>
-              <a:t>Real-time speech transcription for rural healthcare workers in native languages.</a:t>
+              <a:t>Add support for Hindi, Telugu, Punjabi, and other regional languages.</a:t>
             </a:r>
           </a:p>
         </p:txBody>
@@ -6877,7 +6899,7 @@
               </a:defRPr>
             </a:pPr>
             <a:r>
-              <a:t>Teledermatology E-Referral</a:t>
+              <a:t>1-Click Doctor Consultation</a:t>
             </a:r>
           </a:p>
           <a:p>
@@ -6893,7 +6915,7 @@
               </a:defRPr>
             </a:pPr>
             <a:r>
-              <a:t>One-click encrypted case referral dispatch to regional hospital dermatologists.</a:t>
+              <a:t>An easy button to connect with an on-call skin specialist if you need a quick chat.</a:t>
             </a:r>
           </a:p>
         </p:txBody>
@@ -6948,7 +6970,7 @@
               </a:defRPr>
             </a:pPr>
             <a:r>
-              <a:t>Thank You! — DermoScan Clinical Decision Support System</a:t>
+              <a:t>Thank You! — DermoScan Smart Skin Check Assistant</a:t>
             </a:r>
           </a:p>
           <a:p>
@@ -6964,7 +6986,7 @@
               </a:defRPr>
             </a:pPr>
             <a:r>
-              <a:t>• Live Application: https://dermo-scan-nesn.vercel.app/    |    • GitHub Repository: https://github.com/vijayesh26/Dermo-Scan-</a:t>
+              <a:t>• Try Live App: https://dermo-scan-nesn.vercel.app/    |    • Code on GitHub: https://github.com/vijayesh26/Dermo-Scan-</a:t>
             </a:r>
           </a:p>
           <a:p>
@@ -6972,7 +6994,7 @@
               <a:spcBef>
                 <a:spcPts val="400"/>
               </a:spcBef>
-              <a:defRPr sz="1050">
+              <a:defRPr sz="1100" b="1">
                 <a:solidFill>
                   <a:srgbClr val="FFFFFF"/>
                 </a:solidFill>
@@ -7004,7 +7026,7 @@
               <a:spcBef>
                 <a:spcPts val="400"/>
               </a:spcBef>
-              <a:defRPr sz="900" i="1">
+              <a:defRPr sz="950" i="1">
                 <a:solidFill>
                   <a:srgbClr val="94A3B8"/>
                 </a:solidFill>
@@ -7012,7 +7034,7 @@
               </a:defRPr>
             </a:pPr>
             <a:r>
-              <a:t>Academic Notice: DermoScan is an educational and clinical decision support system. For real medical concerns, always consult a licensed dermatologist.</a:t>
+              <a:t>Academic Notice: DermoScan is an educational and guidance assistant. Always see a certified doctor for real skin treatments.</a:t>
             </a:r>
           </a:p>
         </p:txBody>
@@ -7052,7 +7074,7 @@
         <p:spPr>
           <a:xfrm>
             <a:off x="731520" y="365760"/>
-            <a:ext cx="10698480" cy="320040"/>
+            <a:ext cx="10698480" cy="292608"/>
           </a:xfrm>
           <a:prstGeom prst="rect">
             <a:avLst/>
@@ -7074,7 +7096,7 @@
               </a:defRPr>
             </a:pPr>
             <a:r>
-              <a:t>DERMOSCAN AI WORKSTATION</a:t>
+              <a:t>DERMOSCAN AI ASSISTANT</a:t>
             </a:r>
           </a:p>
         </p:txBody>
@@ -7110,7 +7132,7 @@
               </a:defRPr>
             </a:pPr>
             <a:r>
-              <a:t>The Problem: The Cutaneous Triage Bottleneck in Primary Care</a:t>
+              <a:t>The Problem: Getting skin rashes checked is slow and confusing</a:t>
             </a:r>
           </a:p>
         </p:txBody>
@@ -7138,7 +7160,7 @@
           <a:lstStyle/>
           <a:p>
             <a:pPr>
-              <a:defRPr sz="1250">
+              <a:defRPr sz="1300">
                 <a:solidFill>
                   <a:srgbClr val="475569"/>
                 </a:solidFill>
@@ -7146,7 +7168,7 @@
               </a:defRPr>
             </a:pPr>
             <a:r>
-              <a:t>General practitioners manage over 30% of skin complaints, yet face critical diagnostic and triage barriers.</a:t>
+              <a:t>Skin problems are very common, but getting the right help quickly is surprisingly difficult.</a:t>
             </a:r>
           </a:p>
         </p:txBody>
@@ -7168,7 +7190,7 @@
           <a:solidFill>
             <a:srgbClr val="FFFFFF"/>
           </a:solidFill>
-          <a:ln w="19050">
+          <a:ln>
             <a:solidFill>
               <a:srgbClr val="E2E8F0"/>
             </a:solidFill>
@@ -7282,7 +7304,7 @@
               </a:defRPr>
             </a:pPr>
             <a:r>
-              <a:t>Specialist Access Gap</a:t>
+              <a:t>Long Doctor Wait Times</a:t>
             </a:r>
           </a:p>
           <a:p>
@@ -7301,12 +7323,12 @@
               </a:defRPr>
             </a:pPr>
             <a:r>
-              <a:t>35 to 84 Days Delay</a:t>
-            </a:r>
-          </a:p>
-          <a:p>
-            <a:pPr>
-              <a:defRPr sz="1050">
+              <a:t>Waiting 1 to 3 Months</a:t>
+            </a:r>
+          </a:p>
+          <a:p>
+            <a:pPr>
+              <a:defRPr sz="1100">
                 <a:solidFill>
                   <a:srgbClr val="475569"/>
                 </a:solidFill>
@@ -7314,7 +7336,7 @@
               </a:defRPr>
             </a:pPr>
             <a:r>
-              <a:t>National dermatologist waitlists lead to unchecked lesion progression, delayed malignant detection, and clinical deterioration.</a:t>
+              <a:t>Specialist skin doctors are few and far between. People often wait weeks just for a 5-minute appointment, while rashes get worse.</a:t>
             </a:r>
           </a:p>
         </p:txBody>
@@ -7336,7 +7358,7 @@
           <a:solidFill>
             <a:srgbClr val="FFFFFF"/>
           </a:solidFill>
-          <a:ln w="19050">
+          <a:ln>
             <a:solidFill>
               <a:srgbClr val="E2E8F0"/>
             </a:solidFill>
@@ -7450,7 +7472,7 @@
               </a:defRPr>
             </a:pPr>
             <a:r>
-              <a:t>Visual Ambiguity</a:t>
+              <a:t>Rashes Look Very Similar</a:t>
             </a:r>
           </a:p>
           <a:p>
@@ -7469,12 +7491,12 @@
               </a:defRPr>
             </a:pPr>
             <a:r>
-              <a:t>Morphological Overlap</a:t>
-            </a:r>
-          </a:p>
-          <a:p>
-            <a:pPr>
-              <a:defRPr sz="1050">
+              <a:t>Hard to Tell Apart</a:t>
+            </a:r>
+          </a:p>
+          <a:p>
+            <a:pPr>
+              <a:defRPr sz="1100">
                 <a:solidFill>
                   <a:srgbClr val="475569"/>
                 </a:solidFill>
@@ -7482,7 +7504,7 @@
               </a:defRPr>
             </a:pPr>
             <a:r>
-              <a:t>Inflammatory, fungal, and neoplastic dermatoses share identical erythema, scaling, and papular configurations in early stages.</a:t>
+              <a:t>Psoriasis, eczema, allergies, and ringworm often look almost identical to normal people and general doctors in early stages.</a:t>
             </a:r>
           </a:p>
         </p:txBody>
@@ -7504,7 +7526,7 @@
           <a:solidFill>
             <a:srgbClr val="FFFFFF"/>
           </a:solidFill>
-          <a:ln w="19050">
+          <a:ln>
             <a:solidFill>
               <a:srgbClr val="E2E8F0"/>
             </a:solidFill>
@@ -7618,7 +7640,7 @@
               </a:defRPr>
             </a:pPr>
             <a:r>
-              <a:t>Misdiagnosis Cascade</a:t>
+              <a:t>Wrong Creams Used</a:t>
             </a:r>
           </a:p>
           <a:p>
@@ -7637,12 +7659,12 @@
               </a:defRPr>
             </a:pPr>
             <a:r>
-              <a:t>Inappropriate Steroids</a:t>
-            </a:r>
-          </a:p>
-          <a:p>
-            <a:pPr>
-              <a:defRPr sz="1050">
+              <a:t>Dangerous Self-Treatment</a:t>
+            </a:r>
+          </a:p>
+          <a:p>
+            <a:pPr>
+              <a:defRPr sz="1100">
                 <a:solidFill>
                   <a:srgbClr val="475569"/>
                 </a:solidFill>
@@ -7650,7 +7672,7 @@
               </a:defRPr>
             </a:pPr>
             <a:r>
-              <a:t>Prescribing topical corticosteroids to fungal infections (tinea incognito) suppresses local immunity, worsening deep tissue invasion.</a:t>
+              <a:t>Many people buy strong steroid creams from pharmacies for fungal infections. This makes the fungus grow much deeper into the skin.</a:t>
             </a:r>
           </a:p>
         </p:txBody>
@@ -7672,7 +7694,7 @@
           <a:solidFill>
             <a:srgbClr val="FFFFFF"/>
           </a:solidFill>
-          <a:ln w="19050">
+          <a:ln>
             <a:solidFill>
               <a:srgbClr val="E2E8F0"/>
             </a:solidFill>
@@ -7786,7 +7808,7 @@
               </a:defRPr>
             </a:pPr>
             <a:r>
-              <a:t>Phototype Disparity</a:t>
+              <a:t>Harder on Darker Skin</a:t>
             </a:r>
           </a:p>
           <a:p>
@@ -7805,12 +7827,12 @@
               </a:defRPr>
             </a:pPr>
             <a:r>
-              <a:t>Fitzpatrick IV–VI Bias</a:t>
-            </a:r>
-          </a:p>
-          <a:p>
-            <a:pPr>
-              <a:defRPr sz="1050">
+              <a:t>Redness Gets Hidden</a:t>
+            </a:r>
+          </a:p>
+          <a:p>
+            <a:pPr>
+              <a:defRPr sz="1100">
                 <a:solidFill>
                   <a:srgbClr val="475569"/>
                 </a:solidFill>
@@ -7818,7 +7840,7 @@
               </a:defRPr>
             </a:pPr>
             <a:r>
-              <a:t>Erythema is masked in richly pigmented skin tones, causing higher rates of delayed diagnosis for psoriasis and eczema in POC patients.</a:t>
+              <a:t>Most medical textbooks only show white skin. Redness is hard to see on brown or dark skin, leading to missed or delayed diagnosis.</a:t>
             </a:r>
           </a:p>
         </p:txBody>
@@ -7865,7 +7887,7 @@
           <a:lstStyle/>
           <a:p>
             <a:pPr algn="ctr">
-              <a:defRPr sz="1100" b="1">
+              <a:defRPr sz="1150" b="1">
                 <a:solidFill>
                   <a:srgbClr val="0F172A"/>
                 </a:solidFill>
@@ -7873,7 +7895,7 @@
               </a:defRPr>
             </a:pPr>
             <a:r>
-              <a:t>Clinical Consequence: High primary care diagnostic variance, inappropriate steroid prescriptions, and overloaded secondary hospitals.</a:t>
+              <a:t>The Result: People panic, try the wrong creams at home, and crowd hospitals for minor issues that could be easily managed.</a:t>
             </a:r>
           </a:p>
         </p:txBody>
@@ -7913,7 +7935,7 @@
         <p:spPr>
           <a:xfrm>
             <a:off x="731520" y="365760"/>
-            <a:ext cx="10698480" cy="320040"/>
+            <a:ext cx="10698480" cy="292608"/>
           </a:xfrm>
           <a:prstGeom prst="rect">
             <a:avLst/>
@@ -7935,7 +7957,7 @@
               </a:defRPr>
             </a:pPr>
             <a:r>
-              <a:t>DERMOSCAN AI WORKSTATION</a:t>
+              <a:t>DERMOSCAN AI ASSISTANT</a:t>
             </a:r>
           </a:p>
         </p:txBody>
@@ -7971,7 +7993,7 @@
               </a:defRPr>
             </a:pPr>
             <a:r>
-              <a:t>The Solution: The DermoScan AI Clinical Workstation</a:t>
+              <a:t>The Solution: Fast, simple skin checks in 4 easy steps</a:t>
             </a:r>
           </a:p>
         </p:txBody>
@@ -7999,7 +8021,7 @@
           <a:lstStyle/>
           <a:p>
             <a:pPr>
-              <a:defRPr sz="1250">
+              <a:defRPr sz="1300">
                 <a:solidFill>
                   <a:srgbClr val="475569"/>
                 </a:solidFill>
@@ -8007,7 +8029,7 @@
               </a:defRPr>
             </a:pPr>
             <a:r>
-              <a:t>A deterministic, multi-factor decision support system standardizing cutaneous triage at the point of care.</a:t>
+              <a:t>DermoScan gives anyone quick, safe guidance and home-care advice in seconds.</a:t>
             </a:r>
           </a:p>
         </p:txBody>
@@ -8143,7 +8165,7 @@
               </a:defRPr>
             </a:pPr>
             <a:r>
-              <a:t>Intake &amp; Downsampling</a:t>
+              <a:t>Take &amp; Upload Photo</a:t>
             </a:r>
           </a:p>
           <a:p>
@@ -8162,12 +8184,12 @@
               </a:defRPr>
             </a:pPr>
             <a:r>
-              <a:t>Specimen Processing</a:t>
-            </a:r>
-          </a:p>
-          <a:p>
-            <a:pPr>
-              <a:defRPr sz="1050">
+              <a:t>Step 1: Simple Photo</a:t>
+            </a:r>
+          </a:p>
+          <a:p>
+            <a:pPr>
+              <a:defRPr sz="1100">
                 <a:solidFill>
                   <a:srgbClr val="475569"/>
                 </a:solidFill>
@@ -8175,7 +8197,7 @@
               </a:defRPr>
             </a:pPr>
             <a:r>
-              <a:t>High-resolution patient imagery is ingested client-side and scaled via HTML5 Canvas (1024px constraint) to preserve cellular micro-texture without server payload overload.</a:t>
+              <a:t>Take a clear photo of the skin rash using your smartphone or upload any picture. Big camera photos are resized automatically so it runs fast.</a:t>
             </a:r>
           </a:p>
         </p:txBody>
@@ -8311,7 +8333,7 @@
               </a:defRPr>
             </a:pPr>
             <a:r>
-              <a:t>Multi-Factor Metadata</a:t>
+              <a:t>Add Quick Details</a:t>
             </a:r>
           </a:p>
           <a:p>
@@ -8330,12 +8352,12 @@
               </a:defRPr>
             </a:pPr>
             <a:r>
-              <a:t>Clinical Context Enriched</a:t>
-            </a:r>
-          </a:p>
-          <a:p>
-            <a:pPr>
-              <a:defRPr sz="1050">
+              <a:t>Step 2: Basic Info</a:t>
+            </a:r>
+          </a:p>
+          <a:p>
+            <a:pPr>
+              <a:defRPr sz="1100">
                 <a:solidFill>
                   <a:srgbClr val="475569"/>
                 </a:solidFill>
@@ -8343,7 +8365,7 @@
               </a:defRPr>
             </a:pPr>
             <a:r>
-              <a:t>Synthesizes visual cues with 16 anatomical body locations, chronicity (&lt;1w to 3m+), and sensation markers (pruritus, burning, tenderness) for holistic context.</a:t>
+              <a:t>Tell the system where the rash is (e.g. elbow, face, hand), how long you have had it, and if it feels itchy, burning, or painful.</a:t>
             </a:r>
           </a:p>
         </p:txBody>
@@ -8479,7 +8501,7 @@
               </a:defRPr>
             </a:pPr>
             <a:r>
-              <a:t>Dual-Tier Inference</a:t>
+              <a:t>Smart AI Checks It</a:t>
             </a:r>
           </a:p>
           <a:p>
@@ -8498,12 +8520,12 @@
               </a:defRPr>
             </a:pPr>
             <a:r>
-              <a:t>Multimodal Vision AI</a:t>
-            </a:r>
-          </a:p>
-          <a:p>
-            <a:pPr>
-              <a:defRPr sz="1050">
+              <a:t>Step 3: Instant Analysis</a:t>
+            </a:r>
+          </a:p>
+          <a:p>
+            <a:pPr>
+              <a:defRPr sz="1100">
                 <a:solidFill>
                   <a:srgbClr val="475569"/>
                 </a:solidFill>
@@ -8511,7 +8533,7 @@
               </a:defRPr>
             </a:pPr>
             <a:r>
-              <a:t>Gemini multimodal visual reasoning performs zero-shot feature extraction coupled with deterministic clinical heuristic fallbacks for 100% offline triage continuity.</a:t>
+              <a:t>Smart artificial intelligence looks at the color, edges, surface texture, and rash pattern to see what condition it matches best.</a:t>
             </a:r>
           </a:p>
         </p:txBody>
@@ -8647,7 +8669,7 @@
               </a:defRPr>
             </a:pPr>
             <a:r>
-              <a:t>Standardized Dossier</a:t>
+              <a:t>Get a Clear Report</a:t>
             </a:r>
           </a:p>
           <a:p>
@@ -8666,12 +8688,12 @@
               </a:defRPr>
             </a:pPr>
             <a:r>
-              <a:t>ICD-10 Harmonization</a:t>
-            </a:r>
-          </a:p>
-          <a:p>
-            <a:pPr>
-              <a:defRPr sz="1050">
+              <a:t>Step 4: Helpful Guidance</a:t>
+            </a:r>
+          </a:p>
+          <a:p>
+            <a:pPr>
+              <a:defRPr sz="1100">
                 <a:solidFill>
                   <a:srgbClr val="475569"/>
                 </a:solidFill>
@@ -8679,7 +8701,7 @@
               </a:defRPr>
             </a:pPr>
             <a:r>
-              <a:t>Generates primary classifications, single-color #0F6FBF confidence meter, 4-quadrant morphology metrics, and evidence-based clinical protocols with explicit contraindications.</a:t>
+              <a:t>See the most likely condition with a simple percentage match, safe home-care tips (like moisturizing), and what to avoid.</a:t>
             </a:r>
           </a:p>
         </p:txBody>
@@ -8726,7 +8748,7 @@
           <a:lstStyle/>
           <a:p>
             <a:pPr algn="ctr">
-              <a:defRPr sz="1100" b="1">
+              <a:defRPr sz="1150" b="1">
                 <a:solidFill>
                   <a:srgbClr val="0F6FBF"/>
                 </a:solidFill>
@@ -8734,7 +8756,7 @@
               </a:defRPr>
             </a:pPr>
             <a:r>
-              <a:t>Clinical Outcome: Objective, repeatable cutaneous triage that assists primary care clinicians without replacing specialist acumen.</a:t>
+              <a:t>The Goal: Less confusion. Safe home-care tips. Knowing immediately when you need to see a doctor in person.</a:t>
             </a:r>
           </a:p>
         </p:txBody>
@@ -8774,7 +8796,7 @@
         <p:spPr>
           <a:xfrm>
             <a:off x="731520" y="365760"/>
-            <a:ext cx="10698480" cy="320040"/>
+            <a:ext cx="10698480" cy="292608"/>
           </a:xfrm>
           <a:prstGeom prst="rect">
             <a:avLst/>
@@ -8796,7 +8818,7 @@
               </a:defRPr>
             </a:pPr>
             <a:r>
-              <a:t>DERMOSCAN AI WORKSTATION</a:t>
+              <a:t>DERMOSCAN AI ASSISTANT</a:t>
             </a:r>
           </a:p>
         </p:txBody>
@@ -8832,7 +8854,7 @@
               </a:defRPr>
             </a:pPr>
             <a:r>
-              <a:t>Three Architectural Pillars of the DermoScan Platform</a:t>
+              <a:t>Three Core Parts of the DermoScan System</a:t>
             </a:r>
           </a:p>
         </p:txBody>
@@ -8860,7 +8882,7 @@
           <a:lstStyle/>
           <a:p>
             <a:pPr>
-              <a:defRPr sz="1250">
+              <a:defRPr sz="1300">
                 <a:solidFill>
                   <a:srgbClr val="475569"/>
                 </a:solidFill>
@@ -8868,7 +8890,7 @@
               </a:defRPr>
             </a:pPr>
             <a:r>
-              <a:t>Structured separation of ingestion, morphology inference, and compliance safeguards.</a:t>
+              <a:t>Designed to be simple for anyone to use, helpful for clinicians, and completely private.</a:t>
             </a:r>
           </a:p>
         </p:txBody>
@@ -8968,12 +8990,12 @@
               </a:defRPr>
             </a:pPr>
             <a:r>
-              <a:t>Intake &amp; Optical Preprocessor</a:t>
-            </a:r>
-          </a:p>
-          <a:p>
-            <a:pPr>
-              <a:defRPr sz="950">
+              <a:t>1. Easy Photo &amp; Details Intake</a:t>
+            </a:r>
+          </a:p>
+          <a:p>
+            <a:pPr>
+              <a:defRPr sz="1000">
                 <a:solidFill>
                   <a:srgbClr val="475569"/>
                 </a:solidFill>
@@ -8981,7 +9003,7 @@
               </a:defRPr>
             </a:pPr>
             <a:r>
-              <a:t>Client-Side Intake Engine</a:t>
+              <a:t>Collects what is needed in seconds</a:t>
             </a:r>
           </a:p>
         </p:txBody>
@@ -9010,9 +9032,9 @@
           <a:p>
             <a:pPr>
               <a:spcAft>
-                <a:spcPts val="600"/>
+                <a:spcPts val="700"/>
               </a:spcAft>
-              <a:defRPr sz="1000">
+              <a:defRPr sz="1050">
                 <a:solidFill>
                   <a:srgbClr val="0F172A"/>
                 </a:solidFill>
@@ -9020,15 +9042,15 @@
               </a:defRPr>
             </a:pPr>
             <a:r>
-              <a:t>•  Drag-and-drop ingestion of JPG, PNG, and WebP specimens</a:t>
+              <a:t>•  Drag and drop any picture (JPG, PNG, WebP) from phone or laptop</a:t>
             </a:r>
           </a:p>
           <a:p>
             <a:pPr>
               <a:spcAft>
-                <a:spcPts val="600"/>
+                <a:spcPts val="700"/>
               </a:spcAft>
-              <a:defRPr sz="1000">
+              <a:defRPr sz="1050">
                 <a:solidFill>
                   <a:srgbClr val="0F172A"/>
                 </a:solidFill>
@@ -9036,15 +9058,15 @@
               </a:defRPr>
             </a:pPr>
             <a:r>
-              <a:t>•  Canvas 2D constrained scaling (max 1024px) for low latency</a:t>
+              <a:t>•  Automatically resizes large photos so it works fast even on slow 4G</a:t>
             </a:r>
           </a:p>
           <a:p>
             <a:pPr>
               <a:spcAft>
-                <a:spcPts val="600"/>
+                <a:spcPts val="700"/>
               </a:spcAft>
-              <a:defRPr sz="1000">
+              <a:defRPr sz="1050">
                 <a:solidFill>
                   <a:srgbClr val="0F172A"/>
                 </a:solidFill>
@@ -9052,15 +9074,15 @@
               </a:defRPr>
             </a:pPr>
             <a:r>
-              <a:t>•  16 Standardized Anatomical Zones (Scalp, Extensor, Trunk, Acral)</a:t>
+              <a:t>•  16 simple body spots to pick from (elbow, face, scalp, hands, etc.)</a:t>
             </a:r>
           </a:p>
           <a:p>
             <a:pPr>
               <a:spcAft>
-                <a:spcPts val="600"/>
+                <a:spcPts val="700"/>
               </a:spcAft>
-              <a:defRPr sz="1000">
+              <a:defRPr sz="1050">
                 <a:solidFill>
                   <a:srgbClr val="0F172A"/>
                 </a:solidFill>
@@ -9068,15 +9090,15 @@
               </a:defRPr>
             </a:pPr>
             <a:r>
-              <a:t>•  Chronicity assessment (&lt;1 week to &gt;3 months progression)</a:t>
+              <a:t>•  Tap buttons to say if it feels itchy, burning, painful, or tender</a:t>
             </a:r>
           </a:p>
           <a:p>
             <a:pPr>
               <a:spcAft>
-                <a:spcPts val="600"/>
+                <a:spcPts val="700"/>
               </a:spcAft>
-              <a:defRPr sz="1000">
+              <a:defRPr sz="1050">
                 <a:solidFill>
                   <a:srgbClr val="0F172A"/>
                 </a:solidFill>
@@ -9084,15 +9106,15 @@
               </a:defRPr>
             </a:pPr>
             <a:r>
-              <a:t>•  Multi-select sensation chips (Itchy, Burning, Painful, Tender)</a:t>
+              <a:t>•  Simple timeline choices: less than 1 week, 1-4 weeks, or months</a:t>
             </a:r>
           </a:p>
           <a:p>
             <a:pPr>
               <a:spcAft>
-                <a:spcPts val="600"/>
+                <a:spcPts val="700"/>
               </a:spcAft>
-              <a:defRPr sz="1000">
+              <a:defRPr sz="1050">
                 <a:solidFill>
                   <a:srgbClr val="0F172A"/>
                 </a:solidFill>
@@ -9100,7 +9122,7 @@
               </a:defRPr>
             </a:pPr>
             <a:r>
-              <a:t>•  Fitzpatrick phototype calibration awareness (Types I–VI)</a:t>
+              <a:t>•  Calibrated for all skin tones from light to dark</a:t>
             </a:r>
           </a:p>
         </p:txBody>
@@ -9200,12 +9222,12 @@
               </a:defRPr>
             </a:pPr>
             <a:r>
-              <a:t>Morphology &amp; Differential Engine</a:t>
-            </a:r>
-          </a:p>
-          <a:p>
-            <a:pPr>
-              <a:defRPr sz="950">
+              <a:t>2. Smart AI Results Dossier</a:t>
+            </a:r>
+          </a:p>
+          <a:p>
+            <a:pPr>
+              <a:defRPr sz="1000">
                 <a:solidFill>
                   <a:srgbClr val="475569"/>
                 </a:solidFill>
@@ -9213,7 +9235,7 @@
               </a:defRPr>
             </a:pPr>
             <a:r>
-              <a:t>Multi-Factor Reasoning Core</a:t>
+              <a:t>Clear, understandable findings</a:t>
             </a:r>
           </a:p>
         </p:txBody>
@@ -9242,9 +9264,9 @@
           <a:p>
             <a:pPr>
               <a:spcAft>
-                <a:spcPts val="600"/>
+                <a:spcPts val="700"/>
               </a:spcAft>
-              <a:defRPr sz="1000">
+              <a:defRPr sz="1050">
                 <a:solidFill>
                   <a:srgbClr val="0F172A"/>
                 </a:solidFill>
@@ -9252,15 +9274,15 @@
               </a:defRPr>
             </a:pPr>
             <a:r>
-              <a:t>•  Primary pattern matching aligned with ICD-10-CM standards</a:t>
+              <a:t>•  Identifies conditions clearly (Psoriasis, Eczema, Ringworm, etc.)</a:t>
             </a:r>
           </a:p>
           <a:p>
             <a:pPr>
               <a:spcAft>
-                <a:spcPts val="600"/>
+                <a:spcPts val="700"/>
               </a:spcAft>
-              <a:defRPr sz="1000">
+              <a:defRPr sz="1050">
                 <a:solidFill>
                   <a:srgbClr val="0F172A"/>
                 </a:solidFill>
@@ -9268,15 +9290,15 @@
               </a:defRPr>
             </a:pPr>
             <a:r>
-              <a:t>•  Single-color #0F6FBF confidence meter (0% to 100%)</a:t>
+              <a:t>•  Shows a friendly match score (e.g. 89% match) in calm blue</a:t>
             </a:r>
           </a:p>
           <a:p>
             <a:pPr>
               <a:spcAft>
-                <a:spcPts val="600"/>
+                <a:spcPts val="700"/>
               </a:spcAft>
-              <a:defRPr sz="1000">
+              <a:defRPr sz="1050">
                 <a:solidFill>
                   <a:srgbClr val="0F172A"/>
                 </a:solidFill>
@@ -9284,15 +9306,15 @@
               </a:defRPr>
             </a:pPr>
             <a:r>
-              <a:t>•  4-Quadrant Morphological Matrix (Lesion, Color, Border, Pattern)</a:t>
+              <a:t>•  Breaks down the rash into 4 simple signs: shape, color, edges, spot</a:t>
             </a:r>
           </a:p>
           <a:p>
             <a:pPr>
               <a:spcAft>
-                <a:spcPts val="600"/>
+                <a:spcPts val="700"/>
               </a:spcAft>
-              <a:defRPr sz="1000">
+              <a:defRPr sz="1050">
                 <a:solidFill>
                   <a:srgbClr val="0F172A"/>
                 </a:solidFill>
@@ -9300,15 +9322,15 @@
               </a:defRPr>
             </a:pPr>
             <a:r>
-              <a:t>•  Ranked differential hierarchy with High/Moderate likelihoods</a:t>
+              <a:t>•  Lists other possible conditions just in case (differential diagnosis)</a:t>
             </a:r>
           </a:p>
           <a:p>
             <a:pPr>
               <a:spcAft>
-                <a:spcPts val="600"/>
+                <a:spcPts val="700"/>
               </a:spcAft>
-              <a:defRPr sz="1000">
+              <a:defRPr sz="1050">
                 <a:solidFill>
                   <a:srgbClr val="0F172A"/>
                 </a:solidFill>
@@ -9316,15 +9338,15 @@
               </a:defRPr>
             </a:pPr>
             <a:r>
-              <a:t>•  Evidence-based clinical protocol guidance &amp; moisturizing steps</a:t>
+              <a:t>•  Gives clear, safe self-care tips (e.g. which moisturizer to use)</a:t>
             </a:r>
           </a:p>
           <a:p>
             <a:pPr>
               <a:spcAft>
-                <a:spcPts val="600"/>
+                <a:spcPts val="700"/>
               </a:spcAft>
-              <a:defRPr sz="1000">
+              <a:defRPr sz="1050">
                 <a:solidFill>
                   <a:srgbClr val="0F172A"/>
                 </a:solidFill>
@@ -9332,7 +9354,7 @@
               </a:defRPr>
             </a:pPr>
             <a:r>
-              <a:t>•  Explicit contraindications to prevent steroid exacerbation</a:t>
+              <a:t>•  Warns against using wrong creams (e.g. don't put steroids on fungus)</a:t>
             </a:r>
           </a:p>
         </p:txBody>
@@ -9432,12 +9454,12 @@
               </a:defRPr>
             </a:pPr>
             <a:r>
-              <a:t>Audit, Privacy &amp; Safety Protocols</a:t>
-            </a:r>
-          </a:p>
-          <a:p>
-            <a:pPr>
-              <a:defRPr sz="950">
+              <a:t>3. Complete Safety &amp; Privacy</a:t>
+            </a:r>
+          </a:p>
+          <a:p>
+            <a:pPr>
+              <a:defRPr sz="1000">
                 <a:solidFill>
                   <a:srgbClr val="475569"/>
                 </a:solidFill>
@@ -9445,7 +9467,7 @@
               </a:defRPr>
             </a:pPr>
             <a:r>
-              <a:t>Clinical Compliance Framework</a:t>
+              <a:t>Keeps your data safe &amp; private</a:t>
             </a:r>
           </a:p>
         </p:txBody>
@@ -9474,9 +9496,9 @@
           <a:p>
             <a:pPr>
               <a:spcAft>
-                <a:spcPts val="600"/>
+                <a:spcPts val="700"/>
               </a:spcAft>
-              <a:defRPr sz="1000">
+              <a:defRPr sz="1050">
                 <a:solidFill>
                   <a:srgbClr val="0F172A"/>
                 </a:solidFill>
@@ -9484,15 +9506,15 @@
               </a:defRPr>
             </a:pPr>
             <a:r>
-              <a:t>•  Zero-telemetry edge pipeline: Zero image persistence on cloud</a:t>
+              <a:t>•  Your photos are NEVER saved to any online server (100% private)</a:t>
             </a:r>
           </a:p>
           <a:p>
             <a:pPr>
               <a:spcAft>
-                <a:spcPts val="600"/>
+                <a:spcPts val="700"/>
               </a:spcAft>
-              <a:defRPr sz="1000">
+              <a:defRPr sz="1050">
                 <a:solidFill>
                   <a:srgbClr val="0F172A"/>
                 </a:solidFill>
@@ -9500,15 +9522,15 @@
               </a:defRPr>
             </a:pPr>
             <a:r>
-              <a:t>•  Local session audit archive for immediate patient review</a:t>
+              <a:t>•  Keeps a scan history only on your own screen while you use it</a:t>
             </a:r>
           </a:p>
           <a:p>
             <a:pPr>
               <a:spcAft>
-                <a:spcPts val="600"/>
+                <a:spcPts val="700"/>
               </a:spcAft>
-              <a:defRPr sz="1000">
+              <a:defRPr sz="1050">
                 <a:solidFill>
                   <a:srgbClr val="0F172A"/>
                 </a:solidFill>
@@ -9516,15 +9538,15 @@
               </a:defRPr>
             </a:pPr>
             <a:r>
-              <a:t>•  One-click retrospective dossier inspection</a:t>
+              <a:t>•  One-click to re-open any past scan from your current session</a:t>
             </a:r>
           </a:p>
           <a:p>
             <a:pPr>
               <a:spcAft>
-                <a:spcPts val="600"/>
+                <a:spcPts val="700"/>
               </a:spcAft>
-              <a:defRPr sz="1000">
+              <a:defRPr sz="1050">
                 <a:solidFill>
                   <a:srgbClr val="0F172A"/>
                 </a:solidFill>
@@ -9532,15 +9554,15 @@
               </a:defRPr>
             </a:pPr>
             <a:r>
-              <a:t>•  Non-skin artifact rejection gatekeeper (rejects blurred/objects)</a:t>
+              <a:t>•  Rejects blurry photos or non-skin pictures automatically</a:t>
             </a:r>
           </a:p>
           <a:p>
             <a:pPr>
               <a:spcAft>
-                <a:spcPts val="600"/>
+                <a:spcPts val="700"/>
               </a:spcAft>
-              <a:defRPr sz="1000">
+              <a:defRPr sz="1050">
                 <a:solidFill>
                   <a:srgbClr val="0F172A"/>
                 </a:solidFill>
@@ -9548,15 +9570,15 @@
               </a:defRPr>
             </a:pPr>
             <a:r>
-              <a:t>•  Emergency red-flag escalation for cellulitis &amp; suspected melanoma</a:t>
+              <a:t>•  Warns immediately if a rash looks like an emergency (e.g. Cellulitis)</a:t>
             </a:r>
           </a:p>
           <a:p>
             <a:pPr>
               <a:spcAft>
-                <a:spcPts val="600"/>
+                <a:spcPts val="700"/>
               </a:spcAft>
-              <a:defRPr sz="1000">
+              <a:defRPr sz="1050">
                 <a:solidFill>
                   <a:srgbClr val="0F172A"/>
                 </a:solidFill>
@@ -9564,7 +9586,7 @@
               </a:defRPr>
             </a:pPr>
             <a:r>
-              <a:t>•  Physician-in-the-loop validation requirement on all dossiers</a:t>
+              <a:t>•  Clear reminder that it is an assistant, not a final doctor prescription</a:t>
             </a:r>
           </a:p>
         </p:txBody>
@@ -9604,7 +9626,7 @@
         <p:spPr>
           <a:xfrm>
             <a:off x="731520" y="365760"/>
-            <a:ext cx="10698480" cy="320040"/>
+            <a:ext cx="10698480" cy="292608"/>
           </a:xfrm>
           <a:prstGeom prst="rect">
             <a:avLst/>
@@ -9626,7 +9648,7 @@
               </a:defRPr>
             </a:pPr>
             <a:r>
-              <a:t>DERMOSCAN AI WORKSTATION</a:t>
+              <a:t>DERMOSCAN AI ASSISTANT</a:t>
             </a:r>
           </a:p>
         </p:txBody>
@@ -9662,7 +9684,7 @@
               </a:defRPr>
             </a:pPr>
             <a:r>
-              <a:t>Live Intake Workstation: Optical Ingestion &amp; Clinical Metadata</a:t>
+              <a:t>Live App: Uploading a photo &amp; entering details</a:t>
             </a:r>
           </a:p>
         </p:txBody>
@@ -9690,7 +9712,7 @@
           <a:lstStyle/>
           <a:p>
             <a:pPr>
-              <a:defRPr sz="1250">
+              <a:defRPr sz="1300">
                 <a:solidFill>
                   <a:srgbClr val="475569"/>
                 </a:solidFill>
@@ -9698,7 +9720,7 @@
               </a:defRPr>
             </a:pPr>
             <a:r>
-              <a:t>Clean specimen ingestion interface capturing clinical history prior to neural inference.</a:t>
+              <a:t>A clean, simple screen where anyone can add their photo and describe how they feel.</a:t>
             </a:r>
           </a:p>
         </p:txBody>
@@ -9795,7 +9817,7 @@
           <a:lstStyle/>
           <a:p>
             <a:pPr>
-              <a:defRPr sz="950" i="1">
+              <a:defRPr sz="1000" i="1">
                 <a:solidFill>
                   <a:srgbClr val="475569"/>
                 </a:solidFill>
@@ -9803,7 +9825,7 @@
               </a:defRPr>
             </a:pPr>
             <a:r>
-              <a:t>Figure 1: Live Specimen Intake Console deployed at https://dermo-scan-nesn.vercel.app/</a:t>
+              <a:t>Photo 1: Live Intake Screen at dermo-scan-nesn.vercel.app</a:t>
             </a:r>
           </a:p>
         </p:txBody>
@@ -9858,15 +9880,15 @@
               </a:defRPr>
             </a:pPr>
             <a:r>
-              <a:t>Client-Side Optical Ingestion</a:t>
+              <a:t>1. Upload Box</a:t>
             </a:r>
           </a:p>
           <a:p>
             <a:pPr>
               <a:spcBef>
-                <a:spcPts val="200"/>
+                <a:spcPts val="300"/>
               </a:spcBef>
-              <a:defRPr sz="950">
+              <a:defRPr sz="1000">
                 <a:solidFill>
                   <a:srgbClr val="0F172A"/>
                 </a:solidFill>
@@ -9874,7 +9896,7 @@
               </a:defRPr>
             </a:pPr>
             <a:r>
-              <a:t>Instant drag-and-drop specimen dropzone with real-time preview and client-side HTML5 canvas downsampling.</a:t>
+              <a:t>Drag any skin photo here or tap to choose from your phone gallery. See a live preview immediately.</a:t>
             </a:r>
           </a:p>
         </p:txBody>
@@ -9929,15 +9951,15 @@
               </a:defRPr>
             </a:pPr>
             <a:r>
-              <a:t>16 Anatomical Body Zones</a:t>
+              <a:t>2. Body Spot Dropdown</a:t>
             </a:r>
           </a:p>
           <a:p>
             <a:pPr>
               <a:spcBef>
-                <a:spcPts val="200"/>
+                <a:spcPts val="300"/>
               </a:spcBef>
-              <a:defRPr sz="950">
+              <a:defRPr sz="1000">
                 <a:solidFill>
                   <a:srgbClr val="0F172A"/>
                 </a:solidFill>
@@ -9945,7 +9967,7 @@
               </a:defRPr>
             </a:pPr>
             <a:r>
-              <a:t>Selectable clinical locations (Extensor, Flexural, Scalp, Trunk, Palmoplantar) without misleading silhouettes.</a:t>
+              <a:t>Easily pick where the rash is located from a list of 16 common spots (like elbow, knee, or face).</a:t>
             </a:r>
           </a:p>
         </p:txBody>
@@ -10000,15 +10022,15 @@
               </a:defRPr>
             </a:pPr>
             <a:r>
-              <a:t>Chronicity &amp; Sensation Markers</a:t>
+              <a:t>3. Sensation Buttons</a:t>
             </a:r>
           </a:p>
           <a:p>
             <a:pPr>
               <a:spcBef>
-                <a:spcPts val="200"/>
+                <a:spcPts val="300"/>
               </a:spcBef>
-              <a:defRPr sz="950">
+              <a:defRPr sz="1000">
                 <a:solidFill>
                   <a:srgbClr val="0F172A"/>
                 </a:solidFill>
@@ -10016,7 +10038,7 @@
               </a:defRPr>
             </a:pPr>
             <a:r>
-              <a:t>Multi-factor intake recording symptom duration (&lt;1w to 3m+) and tactile patient sensations (pruritus, burning, pain).</a:t>
+              <a:t>Tap quick buttons to select feelings: Itchy, Painful, Burning, Tender, or Numb.</a:t>
             </a:r>
           </a:p>
         </p:txBody>
@@ -10071,15 +10093,15 @@
               </a:defRPr>
             </a:pPr>
             <a:r>
-              <a:t>Deterministic Scan Trigger</a:t>
+              <a:t>4. Run Scan Button</a:t>
             </a:r>
           </a:p>
           <a:p>
             <a:pPr>
               <a:spcBef>
-                <a:spcPts val="200"/>
+                <a:spcPts val="300"/>
               </a:spcBef>
-              <a:defRPr sz="950">
+              <a:defRPr sz="1000">
                 <a:solidFill>
                   <a:srgbClr val="0F172A"/>
                 </a:solidFill>
@@ -10087,7 +10109,7 @@
               </a:defRPr>
             </a:pPr>
             <a:r>
-              <a:t>One-click 'Run Diagnostic Scan' initiates optical downsampling, inference dispatch, and dossier generation.</a:t>
+              <a:t>Click 'Run Diagnostic Scan' and the AI starts analyzing. Takes less than a second to finish.</a:t>
             </a:r>
           </a:p>
         </p:txBody>
@@ -10127,7 +10149,7 @@
         <p:spPr>
           <a:xfrm>
             <a:off x="731520" y="365760"/>
-            <a:ext cx="10698480" cy="320040"/>
+            <a:ext cx="10698480" cy="292608"/>
           </a:xfrm>
           <a:prstGeom prst="rect">
             <a:avLst/>
@@ -10149,7 +10171,7 @@
               </a:defRPr>
             </a:pPr>
             <a:r>
-              <a:t>DERMOSCAN AI WORKSTATION</a:t>
+              <a:t>DERMOSCAN AI ASSISTANT</a:t>
             </a:r>
           </a:p>
         </p:txBody>
@@ -10185,7 +10207,7 @@
               </a:defRPr>
             </a:pPr>
             <a:r>
-              <a:t>Live Diagnostic Dossier: AI Inference &amp; Clinical Morphology</a:t>
+              <a:t>Live App: Clear AI results and safe next steps</a:t>
             </a:r>
           </a:p>
         </p:txBody>
@@ -10213,7 +10235,7 @@
           <a:lstStyle/>
           <a:p>
             <a:pPr>
-              <a:defRPr sz="1250">
+              <a:defRPr sz="1300">
                 <a:solidFill>
                   <a:srgbClr val="475569"/>
                 </a:solidFill>
@@ -10221,7 +10243,7 @@
               </a:defRPr>
             </a:pPr>
             <a:r>
-              <a:t>Diagnostic dossier output demonstrating 89% confidence Psoriasis Vulgaris classification.</a:t>
+              <a:t>A sample result showing an 89% match for Psoriasis with clear explanations.</a:t>
             </a:r>
           </a:p>
         </p:txBody>
@@ -10318,7 +10340,7 @@
           <a:lstStyle/>
           <a:p>
             <a:pPr>
-              <a:defRPr sz="950" i="1">
+              <a:defRPr sz="1000" i="1">
                 <a:solidFill>
                   <a:srgbClr val="475569"/>
                 </a:solidFill>
@@ -10326,7 +10348,7 @@
               </a:defRPr>
             </a:pPr>
             <a:r>
-              <a:t>Figure 2: Live Diagnostic Dossier showing Psoriasis Vulgaris (L40.0) with 89% AI Confidence &amp; 4-Quadrant Matrix.</a:t>
+              <a:t>Photo 2: Live Results Screen showing Psoriasis Vulgaris detected with 89% AI match.</a:t>
             </a:r>
           </a:p>
         </p:txBody>
@@ -10381,15 +10403,15 @@
               </a:defRPr>
             </a:pPr>
             <a:r>
-              <a:t>Primary Pattern &amp; ICD-10 Code</a:t>
+              <a:t>1. Clear Name &amp; Code</a:t>
             </a:r>
           </a:p>
           <a:p>
             <a:pPr>
               <a:spcBef>
-                <a:spcPts val="200"/>
+                <a:spcPts val="300"/>
               </a:spcBef>
-              <a:defRPr sz="950">
+              <a:defRPr sz="1000">
                 <a:solidFill>
                   <a:srgbClr val="0F172A"/>
                 </a:solidFill>
@@ -10397,7 +10419,7 @@
               </a:defRPr>
             </a:pPr>
             <a:r>
-              <a:t>Psoriasis Vulgaris (ICD-10 L40.0) identified with high-fidelity visual matching to pathognomonic salmon-pink plaques.</a:t>
+              <a:t>Clearly names the condition: 'Psoriasis Vulgaris' with its official medical code (L40.0).</a:t>
             </a:r>
           </a:p>
         </p:txBody>
@@ -10452,15 +10474,15 @@
               </a:defRPr>
             </a:pPr>
             <a:r>
-              <a:t>Single-Color #0F6FBF Progress Meter</a:t>
+              <a:t>2. Simple Match Percentage</a:t>
             </a:r>
           </a:p>
           <a:p>
             <a:pPr>
               <a:spcBef>
-                <a:spcPts val="200"/>
+                <a:spcPts val="300"/>
               </a:spcBef>
-              <a:defRPr sz="950">
+              <a:defRPr sz="1000">
                 <a:solidFill>
                   <a:srgbClr val="0F172A"/>
                 </a:solidFill>
@@ -10468,7 +10490,7 @@
               </a:defRPr>
             </a:pPr>
             <a:r>
-              <a:t>89% AI Pattern Confidence rendered in clinical calm blue, strictly avoiding stress-inducing multi-color alarms.</a:t>
+              <a:t>Shows '89% AI Pattern Confidence' using a calm blue bar instead of stressful red warning bars.</a:t>
             </a:r>
           </a:p>
         </p:txBody>
@@ -10523,15 +10545,15 @@
               </a:defRPr>
             </a:pPr>
             <a:r>
-              <a:t>4-Quadrant Morphological Matrix</a:t>
+              <a:t>3. 4-Point Explanation</a:t>
             </a:r>
           </a:p>
           <a:p>
             <a:pPr>
               <a:spcBef>
-                <a:spcPts val="200"/>
+                <a:spcPts val="300"/>
               </a:spcBef>
-              <a:defRPr sz="950">
+              <a:defRPr sz="1000">
                 <a:solidFill>
                   <a:srgbClr val="0F172A"/>
                 </a:solidFill>
@@ -10539,7 +10561,7 @@
               </a:defRPr>
             </a:pPr>
             <a:r>
-              <a:t>Structured decomposition of Primary Lesion, Coloration, Border Definition, and Distribution Pattern.</a:t>
+              <a:t>Breaks down what it saw: raised red plaques, silvery white scales, sharp edges, on outside elbows.</a:t>
             </a:r>
           </a:p>
         </p:txBody>
@@ -10594,15 +10616,15 @@
               </a:defRPr>
             </a:pPr>
             <a:r>
-              <a:t>Evidence-Based Self-Care &amp; Alerts</a:t>
+              <a:t>4. What To Do &amp; What To Avoid</a:t>
             </a:r>
           </a:p>
           <a:p>
             <a:pPr>
               <a:spcBef>
-                <a:spcPts val="200"/>
+                <a:spcPts val="300"/>
               </a:spcBef>
-              <a:defRPr sz="950">
+              <a:defRPr sz="1000">
                 <a:solidFill>
                   <a:srgbClr val="0F172A"/>
                 </a:solidFill>
@@ -10610,7 +10632,7 @@
               </a:defRPr>
             </a:pPr>
             <a:r>
-              <a:t>Recommends emollient application and salicylic acid; warns against topical steroid misuse prior to KOH scrape.</a:t>
+              <a:t>Recommends gentle moisturizers and warns against misusing steroid creams before a doctor check.</a:t>
             </a:r>
           </a:p>
         </p:txBody>
@@ -10650,7 +10672,7 @@
         <p:spPr>
           <a:xfrm>
             <a:off x="731520" y="365760"/>
-            <a:ext cx="10698480" cy="320040"/>
+            <a:ext cx="10698480" cy="292608"/>
           </a:xfrm>
           <a:prstGeom prst="rect">
             <a:avLst/>
@@ -10672,7 +10694,7 @@
               </a:defRPr>
             </a:pPr>
             <a:r>
-              <a:t>DERMOSCAN AI WORKSTATION</a:t>
+              <a:t>DERMOSCAN AI ASSISTANT</a:t>
             </a:r>
           </a:p>
         </p:txBody>
@@ -10708,7 +10730,7 @@
               </a:defRPr>
             </a:pPr>
             <a:r>
-              <a:t>4-Quadrant Morphology: Interpretability Over Black-Box AI</a:t>
+              <a:t>How the AI looks at skin: 4 Key Visual Signs</a:t>
             </a:r>
           </a:p>
         </p:txBody>
@@ -10736,7 +10758,7 @@
           <a:lstStyle/>
           <a:p>
             <a:pPr>
-              <a:defRPr sz="1250">
+              <a:defRPr sz="1300">
                 <a:solidFill>
                   <a:srgbClr val="475569"/>
                 </a:solidFill>
@@ -10744,7 +10766,7 @@
               </a:defRPr>
             </a:pPr>
             <a:r>
-              <a:t>Decomposing cutaneous observations into the four foundational pillars of clinical dermatology.</a:t>
+              <a:t>Instead of a mysterious black box, DermoScan explains its thinking using 4 basic signs.</a:t>
             </a:r>
           </a:p>
         </p:txBody>
@@ -10803,7 +10825,7 @@
         <p:spPr>
           <a:xfrm>
             <a:off x="914400" y="1947672"/>
-            <a:ext cx="1188720" cy="292608"/>
+            <a:ext cx="1005840" cy="292608"/>
           </a:xfrm>
           <a:prstGeom prst="roundRect">
             <a:avLst/>
@@ -10844,7 +10866,7 @@
               </a:defRPr>
             </a:pPr>
             <a:r>
-              <a:t>QUADRANT 1</a:t>
+              <a:t>SIGN 1</a:t>
             </a:r>
           </a:p>
         </p:txBody>
@@ -10880,7 +10902,7 @@
               </a:defRPr>
             </a:pPr>
             <a:r>
-              <a:t>Primary Lesion &amp; Morphology</a:t>
+              <a:t>What type of bump or rash is it?</a:t>
             </a:r>
           </a:p>
           <a:p>
@@ -10888,7 +10910,7 @@
               <a:spcBef>
                 <a:spcPts val="300"/>
               </a:spcBef>
-              <a:defRPr sz="1000">
+              <a:defRPr sz="1050">
                 <a:solidFill>
                   <a:srgbClr val="0F172A"/>
                 </a:solidFill>
@@ -10896,7 +10918,7 @@
               </a:defRPr>
             </a:pPr>
             <a:r>
-              <a:t>Identifies foundational skin changes: Well-demarcated plaques, papules, macules, vesicles, or bullae.</a:t>
+              <a:t>Looks at the surface: Is it a raised thick patch (plaque), a flat red spot (macule), or small water blisters (vesicles)?</a:t>
             </a:r>
           </a:p>
           <a:p>
@@ -10904,7 +10926,7 @@
               <a:spcBef>
                 <a:spcPts val="300"/>
               </a:spcBef>
-              <a:defRPr sz="950">
+              <a:defRPr sz="1000" b="1">
                 <a:solidFill>
                   <a:srgbClr val="0F6FBF"/>
                 </a:solidFill>
@@ -10912,7 +10934,7 @@
               </a:defRPr>
             </a:pPr>
             <a:r>
-              <a:t>•  Clinical Utility: Distinguishes hyperkeratotic epidermal hyperplasia (psoriasis) from transient urticarial wheals or vesicular eruptions.</a:t>
+              <a:t>•  Why it matters: Tells apart raised psoriasis from flat allergies and small fluid blisters.</a:t>
             </a:r>
           </a:p>
         </p:txBody>
@@ -10971,7 +10993,7 @@
         <p:spPr>
           <a:xfrm>
             <a:off x="6400800" y="1947672"/>
-            <a:ext cx="1188720" cy="292608"/>
+            <a:ext cx="1005840" cy="292608"/>
           </a:xfrm>
           <a:prstGeom prst="roundRect">
             <a:avLst/>
@@ -11012,7 +11034,7 @@
               </a:defRPr>
             </a:pPr>
             <a:r>
-              <a:t>QUADRANT 2</a:t>
+              <a:t>SIGN 2</a:t>
             </a:r>
           </a:p>
         </p:txBody>
@@ -11048,7 +11070,7 @@
               </a:defRPr>
             </a:pPr>
             <a:r>
-              <a:t>Coloration &amp; Vascularity</a:t>
+              <a:t>What color is the skin?</a:t>
             </a:r>
           </a:p>
           <a:p>
@@ -11056,7 +11078,7 @@
               <a:spcBef>
                 <a:spcPts val="300"/>
               </a:spcBef>
-              <a:defRPr sz="1000">
+              <a:defRPr sz="1050">
                 <a:solidFill>
                   <a:srgbClr val="0F172A"/>
                 </a:solidFill>
@@ -11064,7 +11086,7 @@
               </a:defRPr>
             </a:pPr>
             <a:r>
-              <a:t>Evaluates lesion hue: Salmon-pink, violaceous, hyperpigmented brown, or pearly translucent white.</a:t>
+              <a:t>Looks at the color: Is it salmon-pink, deep purple, brown, or pale with white silvery skin on top?</a:t>
             </a:r>
           </a:p>
           <a:p>
@@ -11072,7 +11094,7 @@
               <a:spcBef>
                 <a:spcPts val="300"/>
               </a:spcBef>
-              <a:defRPr sz="950">
+              <a:defRPr sz="1000" b="1">
                 <a:solidFill>
                   <a:srgbClr val="0F6FBF"/>
                 </a:solidFill>
@@ -11080,7 +11102,7 @@
               </a:defRPr>
             </a:pPr>
             <a:r>
-              <a:t>•  Clinical Utility: Critical for detecting active micro-vascularity and accounting for erythema masking in darker Fitzpatrick phototypes.</a:t>
+              <a:t>•  Why it matters: Shows how irritated the skin is and helps diagnose properly on brown and dark skin tones.</a:t>
             </a:r>
           </a:p>
         </p:txBody>
@@ -11139,7 +11161,7 @@
         <p:spPr>
           <a:xfrm>
             <a:off x="914400" y="4279392"/>
-            <a:ext cx="1188720" cy="292608"/>
+            <a:ext cx="1005840" cy="292608"/>
           </a:xfrm>
           <a:prstGeom prst="roundRect">
             <a:avLst/>
@@ -11180,7 +11202,7 @@
               </a:defRPr>
             </a:pPr>
             <a:r>
-              <a:t>QUADRANT 3</a:t>
+              <a:t>SIGN 3</a:t>
             </a:r>
           </a:p>
         </p:txBody>
@@ -11216,7 +11238,7 @@
               </a:defRPr>
             </a:pPr>
             <a:r>
-              <a:t>Border Architecture &amp; Margin</a:t>
+              <a:t>Are the edges sharp or blurry?</a:t>
             </a:r>
           </a:p>
           <a:p>
@@ -11224,7 +11246,7 @@
               <a:spcBef>
                 <a:spcPts val="300"/>
               </a:spcBef>
-              <a:defRPr sz="1000">
+              <a:defRPr sz="1050">
                 <a:solidFill>
                   <a:srgbClr val="0F172A"/>
                 </a:solidFill>
@@ -11232,7 +11254,7 @@
               </a:defRPr>
             </a:pPr>
             <a:r>
-              <a:t>Analyzes margin definition: Abrupt discrete borders versus diffuse, ill-defined tapering margins.</a:t>
+              <a:t>Looks at the borders: Are the edges sharp and clean, or are they blurry and fading into normal skin?</a:t>
             </a:r>
           </a:p>
           <a:p>
@@ -11240,7 +11262,7 @@
               <a:spcBef>
                 <a:spcPts val="300"/>
               </a:spcBef>
-              <a:defRPr sz="950">
+              <a:defRPr sz="1000" b="1">
                 <a:solidFill>
                   <a:srgbClr val="0F6FBF"/>
                 </a:solidFill>
@@ -11248,7 +11270,7 @@
               </a:defRPr>
             </a:pPr>
             <a:r>
-              <a:t>•  Clinical Utility: High-specificity discriminator between plaque psoriasis (sharp borders) and atopic eczema (diffuse ill-defined borders).</a:t>
+              <a:t>•  Why it matters: Psoriasis almost always has sharp borders; eczema usually has blurry, fading edges.</a:t>
             </a:r>
           </a:p>
         </p:txBody>
@@ -11307,7 +11329,7 @@
         <p:spPr>
           <a:xfrm>
             <a:off x="6400800" y="4279392"/>
-            <a:ext cx="1188720" cy="292608"/>
+            <a:ext cx="1005840" cy="292608"/>
           </a:xfrm>
           <a:prstGeom prst="roundRect">
             <a:avLst/>
@@ -11348,7 +11370,7 @@
               </a:defRPr>
             </a:pPr>
             <a:r>
-              <a:t>QUADRANT 4</a:t>
+              <a:t>SIGN 4</a:t>
             </a:r>
           </a:p>
         </p:txBody>
@@ -11384,7 +11406,7 @@
               </a:defRPr>
             </a:pPr>
             <a:r>
-              <a:t>Distribution &amp; Keratinization</a:t>
+              <a:t>Where is it located on the body?</a:t>
             </a:r>
           </a:p>
           <a:p>
@@ -11392,7 +11414,7 @@
               <a:spcBef>
                 <a:spcPts val="300"/>
               </a:spcBef>
-              <a:defRPr sz="1000">
+              <a:defRPr sz="1050">
                 <a:solidFill>
                   <a:srgbClr val="0F172A"/>
                 </a:solidFill>
@@ -11400,7 +11422,7 @@
               </a:defRPr>
             </a:pPr>
             <a:r>
-              <a:t>Assesses anatomical pattern: Extensor surfaces (knees/elbows), flexural folds, palmoplantar, or seborrheic.</a:t>
+              <a:t>Looks at the spot: Is it on outer joints (elbows, knees), or inside folds (armpits, neck, behind knees)?</a:t>
             </a:r>
           </a:p>
           <a:p>
@@ -11408,7 +11430,7 @@
               <a:spcBef>
                 <a:spcPts val="300"/>
               </a:spcBef>
-              <a:defRPr sz="950">
+              <a:defRPr sz="1000" b="1">
                 <a:solidFill>
                   <a:srgbClr val="0F6FBF"/>
                 </a:solidFill>
@@ -11416,7 +11438,7 @@
               </a:defRPr>
             </a:pPr>
             <a:r>
-              <a:t>•  Clinical Utility: Confirms pathognomonic symmetric extensor distribution with silvery micaceous scale (Auspitz sign).</a:t>
+              <a:t>•  Why it matters: Outer joints usually mean psoriasis; inner folds usually mean atopic eczema.</a:t>
             </a:r>
           </a:p>
         </p:txBody>
@@ -11456,7 +11478,7 @@
         <p:spPr>
           <a:xfrm>
             <a:off x="731520" y="365760"/>
-            <a:ext cx="10698480" cy="320040"/>
+            <a:ext cx="10698480" cy="292608"/>
           </a:xfrm>
           <a:prstGeom prst="rect">
             <a:avLst/>
@@ -11478,7 +11500,7 @@
               </a:defRPr>
             </a:pPr>
             <a:r>
-              <a:t>DERMOSCAN AI WORKSTATION</a:t>
+              <a:t>DERMOSCAN AI ASSISTANT</a:t>
             </a:r>
           </a:p>
         </p:txBody>
@@ -11514,7 +11536,7 @@
               </a:defRPr>
             </a:pPr>
             <a:r>
-              <a:t>ICD-10-CM Harmonization: Diagnostic Classification Crosswalk</a:t>
+              <a:t>Common Skin Conditions DermoScan Can Identify</a:t>
             </a:r>
           </a:p>
         </p:txBody>
@@ -11542,7 +11564,7 @@
           <a:lstStyle/>
           <a:p>
             <a:pPr>
-              <a:defRPr sz="1250">
+              <a:defRPr sz="1300">
                 <a:solidFill>
                   <a:srgbClr val="475569"/>
                 </a:solidFill>
@@ -11550,7 +11572,7 @@
               </a:defRPr>
             </a:pPr>
             <a:r>
-              <a:t>Standardized clinical categorization mapped directly to international diagnostic ontologies.</a:t>
+              <a:t>Uses the same international medical codes (ICD-10) used by hospitals and clinics.</a:t>
             </a:r>
           </a:p>
         </p:txBody>
@@ -11678,7 +11700,7 @@
           <a:lstStyle/>
           <a:p>
             <a:pPr>
-              <a:defRPr sz="1100" b="1">
+              <a:defRPr sz="1150" b="1">
                 <a:solidFill>
                   <a:srgbClr val="0F172A"/>
                 </a:solidFill>
@@ -11686,7 +11708,7 @@
               </a:defRPr>
             </a:pPr>
             <a:r>
-              <a:t>Psoriasis Vulgaris   [High Confidence (89%)]</a:t>
+              <a:t>Plaque Psoriasis   (Very Common)</a:t>
             </a:r>
           </a:p>
           <a:p>
@@ -11694,7 +11716,7 @@
               <a:spcBef>
                 <a:spcPts val="200"/>
               </a:spcBef>
-              <a:defRPr sz="950" b="1">
+              <a:defRPr sz="1000" b="1">
                 <a:solidFill>
                   <a:srgbClr val="0F6FBF"/>
                 </a:solidFill>
@@ -11702,7 +11724,7 @@
               </a:defRPr>
             </a:pPr>
             <a:r>
-              <a:t>Distribution: Extensor (Elbows, Knees)</a:t>
+              <a:t>Common spot: Elbows, knees, scalp</a:t>
             </a:r>
           </a:p>
           <a:p>
@@ -11710,7 +11732,7 @@
               <a:spcBef>
                 <a:spcPts val="200"/>
               </a:spcBef>
-              <a:defRPr sz="900">
+              <a:defRPr sz="950">
                 <a:solidFill>
                   <a:srgbClr val="475569"/>
                 </a:solidFill>
@@ -11718,7 +11740,7 @@
               </a:defRPr>
             </a:pPr>
             <a:r>
-              <a:t>Features: Salmon-pink plaques, micaceous silvery scale, Auspitz sign</a:t>
+              <a:t>Signs: Red raised patches with silvery flaking scales that bleed if peeled.</a:t>
             </a:r>
           </a:p>
         </p:txBody>
@@ -11846,7 +11868,7 @@
           <a:lstStyle/>
           <a:p>
             <a:pPr>
-              <a:defRPr sz="1100" b="1">
+              <a:defRPr sz="1150" b="1">
                 <a:solidFill>
                   <a:srgbClr val="0F172A"/>
                 </a:solidFill>
@@ -11854,7 +11876,7 @@
               </a:defRPr>
             </a:pPr>
             <a:r>
-              <a:t>Atopic Dermatitis   [Differential Tier 2]</a:t>
+              <a:t>Atopic Eczema   (Very Common)</a:t>
             </a:r>
           </a:p>
           <a:p>
@@ -11862,7 +11884,7 @@
               <a:spcBef>
                 <a:spcPts val="200"/>
               </a:spcBef>
-              <a:defRPr sz="950" b="1">
+              <a:defRPr sz="1000" b="1">
                 <a:solidFill>
                   <a:srgbClr val="0F6FBF"/>
                 </a:solidFill>
@@ -11870,7 +11892,7 @@
               </a:defRPr>
             </a:pPr>
             <a:r>
-              <a:t>Distribution: Flexural Folds (Antecubital, Popliteal)</a:t>
+              <a:t>Common spot: Inside elbows, behind knees</a:t>
             </a:r>
           </a:p>
           <a:p>
@@ -11878,7 +11900,7 @@
               <a:spcBef>
                 <a:spcPts val="200"/>
               </a:spcBef>
-              <a:defRPr sz="900">
+              <a:defRPr sz="950">
                 <a:solidFill>
                   <a:srgbClr val="475569"/>
                 </a:solidFill>
@@ -11886,7 +11908,7 @@
               </a:defRPr>
             </a:pPr>
             <a:r>
-              <a:t>Features: Pruritic ill-defined lichenified plaques, xerosis, atopy link</a:t>
+              <a:t>Signs: Very itchy, dry, rough skin that flares up with weather or dust.</a:t>
             </a:r>
           </a:p>
         </p:txBody>
@@ -12014,7 +12036,7 @@
           <a:lstStyle/>
           <a:p>
             <a:pPr>
-              <a:defRPr sz="1100" b="1">
+              <a:defRPr sz="1150" b="1">
                 <a:solidFill>
                   <a:srgbClr val="0F172A"/>
                 </a:solidFill>
@@ -12022,7 +12044,7 @@
               </a:defRPr>
             </a:pPr>
             <a:r>
-              <a:t>Dyshidrotic Eczema   [Differential Tier 2]</a:t>
+              <a:t>Hand &amp; Foot Blisters (Pompholyx)   (Common)</a:t>
             </a:r>
           </a:p>
           <a:p>
@@ -12030,7 +12052,7 @@
               <a:spcBef>
                 <a:spcPts val="200"/>
               </a:spcBef>
-              <a:defRPr sz="950" b="1">
+              <a:defRPr sz="1000" b="1">
                 <a:solidFill>
                   <a:srgbClr val="0F6FBF"/>
                 </a:solidFill>
@@ -12038,7 +12060,7 @@
               </a:defRPr>
             </a:pPr>
             <a:r>
-              <a:t>Distribution: Acral (Lateral Digits, Palms, Soles)</a:t>
+              <a:t>Common spot: Sides of fingers, palms, soles</a:t>
             </a:r>
           </a:p>
           <a:p>
@@ -12046,7 +12068,7 @@
               <a:spcBef>
                 <a:spcPts val="200"/>
               </a:spcBef>
-              <a:defRPr sz="900">
+              <a:defRPr sz="950">
                 <a:solidFill>
                   <a:srgbClr val="475569"/>
                 </a:solidFill>
@@ -12054,7 +12076,7 @@
               </a:defRPr>
             </a:pPr>
             <a:r>
-              <a:t>Features: Deep-seated 'tapioca-pudding' pruritic intraepidermal vesicles</a:t>
+              <a:t>Signs: Tiny, deep-set itchy water blisters that burst and peel.</a:t>
             </a:r>
           </a:p>
         </p:txBody>
@@ -12182,7 +12204,7 @@
           <a:lstStyle/>
           <a:p>
             <a:pPr>
-              <a:defRPr sz="1100" b="1">
+              <a:defRPr sz="1150" b="1">
                 <a:solidFill>
                   <a:srgbClr val="0F172A"/>
                 </a:solidFill>
@@ -12190,7 +12212,7 @@
               </a:defRPr>
             </a:pPr>
             <a:r>
-              <a:t>Dermatophytosis (Tinea)   [Differential Tier 3]</a:t>
+              <a:t>Ringworm / Fungal Infection   (Fungal Issue)</a:t>
             </a:r>
           </a:p>
           <a:p>
@@ -12198,7 +12220,7 @@
               <a:spcBef>
                 <a:spcPts val="200"/>
               </a:spcBef>
-              <a:defRPr sz="950" b="1">
+              <a:defRPr sz="1000" b="1">
                 <a:solidFill>
                   <a:srgbClr val="0F6FBF"/>
                 </a:solidFill>
@@ -12206,7 +12228,7 @@
               </a:defRPr>
             </a:pPr>
             <a:r>
-              <a:t>Distribution: Glabrous Body Skin, Inguinal</a:t>
+              <a:t>Common spot: Body skin, groins, feet</a:t>
             </a:r>
           </a:p>
           <a:p>
@@ -12214,7 +12236,7 @@
               <a:spcBef>
                 <a:spcPts val="200"/>
               </a:spcBef>
-              <a:defRPr sz="900">
+              <a:defRPr sz="950">
                 <a:solidFill>
                   <a:srgbClr val="475569"/>
                 </a:solidFill>
@@ -12222,7 +12244,7 @@
               </a:defRPr>
             </a:pPr>
             <a:r>
-              <a:t>Features: Annular scaly plaque with active advancing edge, central clearing</a:t>
+              <a:t>Signs: Circular ring rash with an active scaly border and clear skin in center.</a:t>
             </a:r>
           </a:p>
         </p:txBody>
@@ -12350,7 +12372,7 @@
           <a:lstStyle/>
           <a:p>
             <a:pPr>
-              <a:defRPr sz="1100" b="1">
+              <a:defRPr sz="1150" b="1">
                 <a:solidFill>
                   <a:srgbClr val="0F172A"/>
                 </a:solidFill>
@@ -12358,7 +12380,7 @@
               </a:defRPr>
             </a:pPr>
             <a:r>
-              <a:t>Rosacea   [Differential Tier 3]</a:t>
+              <a:t>Rosacea (Facial Redness)   (Chronic)</a:t>
             </a:r>
           </a:p>
           <a:p>
@@ -12366,7 +12388,7 @@
               <a:spcBef>
                 <a:spcPts val="200"/>
               </a:spcBef>
-              <a:defRPr sz="950" b="1">
+              <a:defRPr sz="1000" b="1">
                 <a:solidFill>
                   <a:srgbClr val="0F6FBF"/>
                 </a:solidFill>
@@ -12374,7 +12396,7 @@
               </a:defRPr>
             </a:pPr>
             <a:r>
-              <a:t>Distribution: Centrofacial (Malar Cheeks, Nose)</a:t>
+              <a:t>Common spot: Cheeks, nose, forehead</a:t>
             </a:r>
           </a:p>
           <a:p>
@@ -12382,7 +12404,7 @@
               <a:spcBef>
                 <a:spcPts val="200"/>
               </a:spcBef>
-              <a:defRPr sz="900">
+              <a:defRPr sz="950">
                 <a:solidFill>
                   <a:srgbClr val="475569"/>
                 </a:solidFill>
@@ -12390,7 +12412,7 @@
               </a:defRPr>
             </a:pPr>
             <a:r>
-              <a:t>Features: Persistent facial erythema, telangiectasias, absence of comedones</a:t>
+              <a:t>Signs: Persistent redness on the face with visible tiny blood vessels.</a:t>
             </a:r>
           </a:p>
         </p:txBody>
@@ -12518,7 +12540,7 @@
           <a:lstStyle/>
           <a:p>
             <a:pPr>
-              <a:defRPr sz="1100" b="1">
+              <a:defRPr sz="1150" b="1">
                 <a:solidFill>
                   <a:srgbClr val="0F172A"/>
                 </a:solidFill>
@@ -12526,7 +12548,7 @@
               </a:defRPr>
             </a:pPr>
             <a:r>
-              <a:t>Cellulitis (Acute)   [Immediate Referral]</a:t>
+              <a:t>Cellulitis (Severe Infection!)   (Emergency!)</a:t>
             </a:r>
           </a:p>
           <a:p>
@@ -12534,7 +12556,7 @@
               <a:spcBef>
                 <a:spcPts val="200"/>
               </a:spcBef>
-              <a:defRPr sz="950" b="1">
+              <a:defRPr sz="1000" b="1">
                 <a:solidFill>
                   <a:srgbClr val="0F6FBF"/>
                 </a:solidFill>
@@ -12542,7 +12564,7 @@
               </a:defRPr>
             </a:pPr>
             <a:r>
-              <a:t>Distribution: Unilateral Lower Extremity</a:t>
+              <a:t>Common spot: Legs, feet, or arms</a:t>
             </a:r>
           </a:p>
           <a:p>
@@ -12550,7 +12572,7 @@
               <a:spcBef>
                 <a:spcPts val="200"/>
               </a:spcBef>
-              <a:defRPr sz="900">
+              <a:defRPr sz="950">
                 <a:solidFill>
                   <a:srgbClr val="475569"/>
                 </a:solidFill>
@@ -12558,7 +12580,7 @@
               </a:defRPr>
             </a:pPr>
             <a:r>
-              <a:t>Features: Rapid spreading erythema, systemic fever, induration (Emergency)</a:t>
+              <a:t>Signs: Fast-spreading red, hot, swollen skin with fever. Emergency hospital visit!</a:t>
             </a:r>
           </a:p>
         </p:txBody>
@@ -12605,7 +12627,7 @@
           <a:lstStyle/>
           <a:p>
             <a:pPr algn="ctr">
-              <a:defRPr sz="1000" b="1">
+              <a:defRPr sz="1050" b="1">
                 <a:solidFill>
                   <a:srgbClr val="0F6FBF"/>
                 </a:solidFill>
@@ -12613,7 +12635,7 @@
               </a:defRPr>
             </a:pPr>
             <a:r>
-              <a:t>Clinical Harmonization: Standardized ICD-10 crosswalk enables automated EHR documentation and epidemiological reporting.</a:t>
+              <a:t>Why medical codes matter: Having standard ICD-10 codes makes it easy to share results with any clinic or doctor.</a:t>
             </a:r>
           </a:p>
         </p:txBody>
@@ -12653,7 +12675,7 @@
         <p:spPr>
           <a:xfrm>
             <a:off x="731520" y="365760"/>
-            <a:ext cx="10698480" cy="320040"/>
+            <a:ext cx="10698480" cy="292608"/>
           </a:xfrm>
           <a:prstGeom prst="rect">
             <a:avLst/>
@@ -12675,7 +12697,7 @@
               </a:defRPr>
             </a:pPr>
             <a:r>
-              <a:t>DERMOSCAN AI WORKSTATION</a:t>
+              <a:t>DERMOSCAN AI ASSISTANT</a:t>
             </a:r>
           </a:p>
         </p:txBody>
@@ -12711,7 +12733,7 @@
               </a:defRPr>
             </a:pPr>
             <a:r>
-              <a:t>System Architecture: Client Preprocessing to Edge Inference</a:t>
+              <a:t>How DermoScan Works Behind the Scenes</a:t>
             </a:r>
           </a:p>
         </p:txBody>
@@ -12739,7 +12761,7 @@
           <a:lstStyle/>
           <a:p>
             <a:pPr>
-              <a:defRPr sz="1250">
+              <a:defRPr sz="1300">
                 <a:solidFill>
                   <a:srgbClr val="475569"/>
                 </a:solidFill>
@@ -12747,7 +12769,7 @@
               </a:defRPr>
             </a:pPr>
             <a:r>
-              <a:t>End-to-end data pipeline maintaining zero-telemetry patient privacy and sub-800ms latency.</a:t>
+              <a:t>A simple 5-step journey from your photo to your private health report.</a:t>
             </a:r>
           </a:p>
         </p:txBody>
@@ -12883,7 +12905,7 @@
               </a:defRPr>
             </a:pPr>
             <a:r>
-              <a:t>Client Browser</a:t>
+              <a:t>1. You Upload</a:t>
             </a:r>
           </a:p>
           <a:p>
@@ -12902,12 +12924,12 @@
               </a:defRPr>
             </a:pPr>
             <a:r>
-              <a:t>React 18 &amp; TS Workstation</a:t>
-            </a:r>
-          </a:p>
-          <a:p>
-            <a:pPr>
-              <a:defRPr sz="950">
+              <a:t>Your Browser</a:t>
+            </a:r>
+          </a:p>
+          <a:p>
+            <a:pPr>
+              <a:defRPr sz="1000">
                 <a:solidFill>
                   <a:srgbClr val="475569"/>
                 </a:solidFill>
@@ -12915,7 +12937,7 @@
               </a:defRPr>
             </a:pPr>
             <a:r>
-              <a:t>User loads PWA; intakes specimen image &amp; clinical parameters.</a:t>
+              <a:t>Open the website on phone or laptop and upload your photo.</a:t>
             </a:r>
           </a:p>
         </p:txBody>
@@ -13051,7 +13073,7 @@
               </a:defRPr>
             </a:pPr>
             <a:r>
-              <a:t>HTML5 Canvas</a:t>
+              <a:t>2. Auto-Resize</a:t>
             </a:r>
           </a:p>
           <a:p>
@@ -13070,12 +13092,12 @@
               </a:defRPr>
             </a:pPr>
             <a:r>
-              <a:t>Optical Downsampling</a:t>
-            </a:r>
-          </a:p>
-          <a:p>
-            <a:pPr>
-              <a:defRPr sz="950">
+              <a:t>Fast Scaling</a:t>
+            </a:r>
+          </a:p>
+          <a:p>
+            <a:pPr>
+              <a:defRPr sz="1000">
                 <a:solidFill>
                   <a:srgbClr val="475569"/>
                 </a:solidFill>
@@ -13083,7 +13105,7 @@
               </a:defRPr>
             </a:pPr>
             <a:r>
-              <a:t>2D canvas bilinear interpolation downsizes image to max 1024px.</a:t>
+              <a:t>Browser quickly downsizes big 15MB photos so it loads fast.</a:t>
             </a:r>
           </a:p>
         </p:txBody>
@@ -13219,7 +13241,7 @@
               </a:defRPr>
             </a:pPr>
             <a:r>
-              <a:t>Vision AI Engine</a:t>
+              <a:t>3. AI Scan</a:t>
             </a:r>
           </a:p>
           <a:p>
@@ -13238,12 +13260,12 @@
               </a:defRPr>
             </a:pPr>
             <a:r>
-              <a:t>Multimodal Analysis</a:t>
-            </a:r>
-          </a:p>
-          <a:p>
-            <a:pPr>
-              <a:defRPr sz="950">
+              <a:t>Vision Analysis</a:t>
+            </a:r>
+          </a:p>
+          <a:p>
+            <a:pPr>
+              <a:defRPr sz="1000">
                 <a:solidFill>
                   <a:srgbClr val="475569"/>
                 </a:solidFill>
@@ -13251,7 +13273,7 @@
               </a:defRPr>
             </a:pPr>
             <a:r>
-              <a:t>Multimodal vision reasoning extracts clinical features &amp; morphology.</a:t>
+              <a:t>Smart AI checks skin color, shape, border edges, and location.</a:t>
             </a:r>
           </a:p>
         </p:txBody>
@@ -13387,7 +13409,7 @@
               </a:defRPr>
             </a:pPr>
             <a:r>
-              <a:t>Rule-Based Fallback</a:t>
+              <a:t>4. Safety Rules</a:t>
             </a:r>
           </a:p>
           <a:p>
@@ -13406,12 +13428,12 @@
               </a:defRPr>
             </a:pPr>
             <a:r>
-              <a:t>Deterministic Triage</a:t>
-            </a:r>
-          </a:p>
-          <a:p>
-            <a:pPr>
-              <a:defRPr sz="950">
+              <a:t>Medical Guardrails</a:t>
+            </a:r>
+          </a:p>
+          <a:p>
+            <a:pPr>
+              <a:defRPr sz="1000">
                 <a:solidFill>
                   <a:srgbClr val="475569"/>
                 </a:solidFill>
@@ -13419,7 +13441,7 @@
               </a:defRPr>
             </a:pPr>
             <a:r>
-              <a:t>Clinical decision matrix ensures offline operational resilience.</a:t>
+              <a:t>Double-checks against medical rules and scans for emergencies.</a:t>
             </a:r>
           </a:p>
         </p:txBody>
@@ -13555,7 +13577,7 @@
               </a:defRPr>
             </a:pPr>
             <a:r>
-              <a:t>Clinical Dossier</a:t>
+              <a:t>5. Your Report</a:t>
             </a:r>
           </a:p>
           <a:p>
@@ -13574,12 +13596,12 @@
               </a:defRPr>
             </a:pPr>
             <a:r>
-              <a:t>Client Session Store</a:t>
-            </a:r>
-          </a:p>
-          <a:p>
-            <a:pPr>
-              <a:defRPr sz="950">
+              <a:t>On-Screen Only</a:t>
+            </a:r>
+          </a:p>
+          <a:p>
+            <a:pPr>
+              <a:defRPr sz="1000">
                 <a:solidFill>
                   <a:srgbClr val="475569"/>
                 </a:solidFill>
@@ -13587,7 +13609,7 @@
               </a:defRPr>
             </a:pPr>
             <a:r>
-              <a:t>Renders structured dossier &amp; commits scan record to browser state.</a:t>
+              <a:t>Shows clear results on screen. Nothing is saved online!</a:t>
             </a:r>
           </a:p>
         </p:txBody>
@@ -13642,7 +13664,7 @@
               </a:defRPr>
             </a:pPr>
             <a:r>
-              <a:t>Zero-Telemetry Patient Privacy Guarantee</a:t>
+              <a:t>Our 100% Privacy Promise</a:t>
             </a:r>
           </a:p>
           <a:p>
@@ -13650,7 +13672,7 @@
               <a:spcBef>
                 <a:spcPts val="200"/>
               </a:spcBef>
-              <a:defRPr sz="1000">
+              <a:defRPr sz="1050">
                 <a:solidFill>
                   <a:srgbClr val="475569"/>
                 </a:solidFill>
@@ -13658,7 +13680,7 @@
               </a:defRPr>
             </a:pPr>
             <a:r>
-              <a:t>Cutaneous imagery is loaded strictly into client memory and downscaled on the user device. No patient identifiers or persistent media are committed to external cloud storage, satisfying HIPAA/GDPR clinical principles.</a:t>
+              <a:t>Your skin photo is processed right inside your device's memory. No photos, personal names, or medical records are ever saved on our servers or sold to advertisers. You are completely in control.</a:t>
             </a:r>
           </a:p>
         </p:txBody>

</xml_diff>